<commit_message>
add FSM for bidirectional stream
</commit_message>
<xml_diff>
--- a/rapport/schema.pptx
+++ b/rapport/schema.pptx
@@ -4,9 +4,14 @@
   <p:sldMasterIdLst>
     <p:sldMasterId id="2147483648" r:id="rId1"/>
   </p:sldMasterIdLst>
+  <p:notesMasterIdLst>
+    <p:notesMasterId r:id="rId6"/>
+  </p:notesMasterIdLst>
   <p:sldIdLst>
     <p:sldId id="256" r:id="rId2"/>
     <p:sldId id="257" r:id="rId3"/>
+    <p:sldId id="258" r:id="rId4"/>
+    <p:sldId id="259" r:id="rId5"/>
   </p:sldIdLst>
   <p:sldSz cx="12192000" cy="6858000"/>
   <p:notesSz cx="6858000" cy="9144000"/>
@@ -105,7 +110,538 @@
       </a:defRPr>
     </a:lvl9pPr>
   </p:defaultTextStyle>
+  <p:extLst>
+    <p:ext uri="{EFAFB233-063F-42B5-8137-9DF3F51BA10A}">
+      <p15:sldGuideLst xmlns:p15="http://schemas.microsoft.com/office/powerpoint/2012/main"/>
+    </p:ext>
+  </p:extLst>
 </p:presentation>
+</file>
+
+<file path=ppt/notesMasters/notesMaster1.xml><?xml version="1.0" encoding="utf-8"?>
+<p:notesMaster xmlns:a="http://schemas.openxmlformats.org/drawingml/2006/main" xmlns:r="http://schemas.openxmlformats.org/officeDocument/2006/relationships" xmlns:p="http://schemas.openxmlformats.org/presentationml/2006/main">
+  <p:cSld>
+    <p:bg>
+      <p:bgRef idx="1001">
+        <a:schemeClr val="bg1"/>
+      </p:bgRef>
+    </p:bg>
+    <p:spTree>
+      <p:nvGrpSpPr>
+        <p:cNvPr id="1" name=""/>
+        <p:cNvGrpSpPr/>
+        <p:nvPr/>
+      </p:nvGrpSpPr>
+      <p:grpSpPr>
+        <a:xfrm>
+          <a:off x="0" y="0"/>
+          <a:ext cx="0" cy="0"/>
+          <a:chOff x="0" y="0"/>
+          <a:chExt cx="0" cy="0"/>
+        </a:xfrm>
+      </p:grpSpPr>
+      <p:sp>
+        <p:nvSpPr>
+          <p:cNvPr id="2" name="Espace réservé de l'en-tête 1"/>
+          <p:cNvSpPr>
+            <a:spLocks noGrp="1"/>
+          </p:cNvSpPr>
+          <p:nvPr>
+            <p:ph type="hdr" sz="quarter"/>
+          </p:nvPr>
+        </p:nvSpPr>
+        <p:spPr>
+          <a:xfrm>
+            <a:off x="0" y="0"/>
+            <a:ext cx="2971800" cy="458788"/>
+          </a:xfrm>
+          <a:prstGeom prst="rect">
+            <a:avLst/>
+          </a:prstGeom>
+        </p:spPr>
+        <p:txBody>
+          <a:bodyPr vert="horz" lIns="91440" tIns="45720" rIns="91440" bIns="45720" rtlCol="0"/>
+          <a:lstStyle>
+            <a:lvl1pPr algn="l">
+              <a:defRPr sz="1200"/>
+            </a:lvl1pPr>
+          </a:lstStyle>
+          <a:p>
+            <a:endParaRPr lang="en-GB"/>
+          </a:p>
+        </p:txBody>
+      </p:sp>
+      <p:sp>
+        <p:nvSpPr>
+          <p:cNvPr id="3" name="Espace réservé de la date 2"/>
+          <p:cNvSpPr>
+            <a:spLocks noGrp="1"/>
+          </p:cNvSpPr>
+          <p:nvPr>
+            <p:ph type="dt" idx="1"/>
+          </p:nvPr>
+        </p:nvSpPr>
+        <p:spPr>
+          <a:xfrm>
+            <a:off x="3884613" y="0"/>
+            <a:ext cx="2971800" cy="458788"/>
+          </a:xfrm>
+          <a:prstGeom prst="rect">
+            <a:avLst/>
+          </a:prstGeom>
+        </p:spPr>
+        <p:txBody>
+          <a:bodyPr vert="horz" lIns="91440" tIns="45720" rIns="91440" bIns="45720" rtlCol="0"/>
+          <a:lstStyle>
+            <a:lvl1pPr algn="r">
+              <a:defRPr sz="1200"/>
+            </a:lvl1pPr>
+          </a:lstStyle>
+          <a:p>
+            <a:fld id="{A3D9FBD5-0A08-42A7-A20A-3E938E2C13C1}" type="datetimeFigureOut">
+              <a:rPr lang="en-GB" smtClean="0"/>
+              <a:t>26/09/2020</a:t>
+            </a:fld>
+            <a:endParaRPr lang="en-GB"/>
+          </a:p>
+        </p:txBody>
+      </p:sp>
+      <p:sp>
+        <p:nvSpPr>
+          <p:cNvPr id="4" name="Espace réservé de l'image des diapositives 3"/>
+          <p:cNvSpPr>
+            <a:spLocks noGrp="1" noRot="1" noChangeAspect="1"/>
+          </p:cNvSpPr>
+          <p:nvPr>
+            <p:ph type="sldImg" idx="2"/>
+          </p:nvPr>
+        </p:nvSpPr>
+        <p:spPr>
+          <a:xfrm>
+            <a:off x="685800" y="1143000"/>
+            <a:ext cx="5486400" cy="3086100"/>
+          </a:xfrm>
+          <a:prstGeom prst="rect">
+            <a:avLst/>
+          </a:prstGeom>
+          <a:noFill/>
+          <a:ln w="12700">
+            <a:solidFill>
+              <a:prstClr val="black"/>
+            </a:solidFill>
+          </a:ln>
+        </p:spPr>
+        <p:txBody>
+          <a:bodyPr vert="horz" lIns="91440" tIns="45720" rIns="91440" bIns="45720" rtlCol="0" anchor="ctr"/>
+          <a:lstStyle/>
+          <a:p>
+            <a:endParaRPr lang="en-GB"/>
+          </a:p>
+        </p:txBody>
+      </p:sp>
+      <p:sp>
+        <p:nvSpPr>
+          <p:cNvPr id="5" name="Espace réservé des notes 4"/>
+          <p:cNvSpPr>
+            <a:spLocks noGrp="1"/>
+          </p:cNvSpPr>
+          <p:nvPr>
+            <p:ph type="body" sz="quarter" idx="3"/>
+          </p:nvPr>
+        </p:nvSpPr>
+        <p:spPr>
+          <a:xfrm>
+            <a:off x="685800" y="4400550"/>
+            <a:ext cx="5486400" cy="3600450"/>
+          </a:xfrm>
+          <a:prstGeom prst="rect">
+            <a:avLst/>
+          </a:prstGeom>
+        </p:spPr>
+        <p:txBody>
+          <a:bodyPr vert="horz" lIns="91440" tIns="45720" rIns="91440" bIns="45720" rtlCol="0"/>
+          <a:lstStyle/>
+          <a:p>
+            <a:pPr lvl="0"/>
+            <a:r>
+              <a:rPr lang="fr-FR"/>
+              <a:t>Cliquez pour modifier les styles du texte du masque</a:t>
+            </a:r>
+          </a:p>
+          <a:p>
+            <a:pPr lvl="1"/>
+            <a:r>
+              <a:rPr lang="fr-FR"/>
+              <a:t>Deuxième niveau</a:t>
+            </a:r>
+          </a:p>
+          <a:p>
+            <a:pPr lvl="2"/>
+            <a:r>
+              <a:rPr lang="fr-FR"/>
+              <a:t>Troisième niveau</a:t>
+            </a:r>
+          </a:p>
+          <a:p>
+            <a:pPr lvl="3"/>
+            <a:r>
+              <a:rPr lang="fr-FR"/>
+              <a:t>Quatrième niveau</a:t>
+            </a:r>
+          </a:p>
+          <a:p>
+            <a:pPr lvl="4"/>
+            <a:r>
+              <a:rPr lang="fr-FR"/>
+              <a:t>Cinquième niveau</a:t>
+            </a:r>
+            <a:endParaRPr lang="en-GB"/>
+          </a:p>
+        </p:txBody>
+      </p:sp>
+      <p:sp>
+        <p:nvSpPr>
+          <p:cNvPr id="6" name="Espace réservé du pied de page 5"/>
+          <p:cNvSpPr>
+            <a:spLocks noGrp="1"/>
+          </p:cNvSpPr>
+          <p:nvPr>
+            <p:ph type="ftr" sz="quarter" idx="4"/>
+          </p:nvPr>
+        </p:nvSpPr>
+        <p:spPr>
+          <a:xfrm>
+            <a:off x="0" y="8685213"/>
+            <a:ext cx="2971800" cy="458787"/>
+          </a:xfrm>
+          <a:prstGeom prst="rect">
+            <a:avLst/>
+          </a:prstGeom>
+        </p:spPr>
+        <p:txBody>
+          <a:bodyPr vert="horz" lIns="91440" tIns="45720" rIns="91440" bIns="45720" rtlCol="0" anchor="b"/>
+          <a:lstStyle>
+            <a:lvl1pPr algn="l">
+              <a:defRPr sz="1200"/>
+            </a:lvl1pPr>
+          </a:lstStyle>
+          <a:p>
+            <a:endParaRPr lang="en-GB"/>
+          </a:p>
+        </p:txBody>
+      </p:sp>
+      <p:sp>
+        <p:nvSpPr>
+          <p:cNvPr id="7" name="Espace réservé du numéro de diapositive 6"/>
+          <p:cNvSpPr>
+            <a:spLocks noGrp="1"/>
+          </p:cNvSpPr>
+          <p:nvPr>
+            <p:ph type="sldNum" sz="quarter" idx="5"/>
+          </p:nvPr>
+        </p:nvSpPr>
+        <p:spPr>
+          <a:xfrm>
+            <a:off x="3884613" y="8685213"/>
+            <a:ext cx="2971800" cy="458787"/>
+          </a:xfrm>
+          <a:prstGeom prst="rect">
+            <a:avLst/>
+          </a:prstGeom>
+        </p:spPr>
+        <p:txBody>
+          <a:bodyPr vert="horz" lIns="91440" tIns="45720" rIns="91440" bIns="45720" rtlCol="0" anchor="b"/>
+          <a:lstStyle>
+            <a:lvl1pPr algn="r">
+              <a:defRPr sz="1200"/>
+            </a:lvl1pPr>
+          </a:lstStyle>
+          <a:p>
+            <a:fld id="{7512EB12-3C52-4A5B-9741-32EF9D1D721D}" type="slidenum">
+              <a:rPr lang="en-GB" smtClean="0"/>
+              <a:t>‹N°›</a:t>
+            </a:fld>
+            <a:endParaRPr lang="en-GB"/>
+          </a:p>
+        </p:txBody>
+      </p:sp>
+    </p:spTree>
+    <p:extLst>
+      <p:ext uri="{BB962C8B-B14F-4D97-AF65-F5344CB8AC3E}">
+        <p14:creationId xmlns:p14="http://schemas.microsoft.com/office/powerpoint/2010/main" val="110179412"/>
+      </p:ext>
+    </p:extLst>
+  </p:cSld>
+  <p:clrMap bg1="lt1" tx1="dk1" bg2="lt2" tx2="dk2" accent1="accent1" accent2="accent2" accent3="accent3" accent4="accent4" accent5="accent5" accent6="accent6" hlink="hlink" folHlink="folHlink"/>
+  <p:notesStyle>
+    <a:lvl1pPr marL="0" algn="l" defTabSz="914400" rtl="0" eaLnBrk="1" latinLnBrk="0" hangingPunct="1">
+      <a:defRPr sz="1200" kern="1200">
+        <a:solidFill>
+          <a:schemeClr val="tx1"/>
+        </a:solidFill>
+        <a:latin typeface="+mn-lt"/>
+        <a:ea typeface="+mn-ea"/>
+        <a:cs typeface="+mn-cs"/>
+      </a:defRPr>
+    </a:lvl1pPr>
+    <a:lvl2pPr marL="457200" algn="l" defTabSz="914400" rtl="0" eaLnBrk="1" latinLnBrk="0" hangingPunct="1">
+      <a:defRPr sz="1200" kern="1200">
+        <a:solidFill>
+          <a:schemeClr val="tx1"/>
+        </a:solidFill>
+        <a:latin typeface="+mn-lt"/>
+        <a:ea typeface="+mn-ea"/>
+        <a:cs typeface="+mn-cs"/>
+      </a:defRPr>
+    </a:lvl2pPr>
+    <a:lvl3pPr marL="914400" algn="l" defTabSz="914400" rtl="0" eaLnBrk="1" latinLnBrk="0" hangingPunct="1">
+      <a:defRPr sz="1200" kern="1200">
+        <a:solidFill>
+          <a:schemeClr val="tx1"/>
+        </a:solidFill>
+        <a:latin typeface="+mn-lt"/>
+        <a:ea typeface="+mn-ea"/>
+        <a:cs typeface="+mn-cs"/>
+      </a:defRPr>
+    </a:lvl3pPr>
+    <a:lvl4pPr marL="1371600" algn="l" defTabSz="914400" rtl="0" eaLnBrk="1" latinLnBrk="0" hangingPunct="1">
+      <a:defRPr sz="1200" kern="1200">
+        <a:solidFill>
+          <a:schemeClr val="tx1"/>
+        </a:solidFill>
+        <a:latin typeface="+mn-lt"/>
+        <a:ea typeface="+mn-ea"/>
+        <a:cs typeface="+mn-cs"/>
+      </a:defRPr>
+    </a:lvl4pPr>
+    <a:lvl5pPr marL="1828800" algn="l" defTabSz="914400" rtl="0" eaLnBrk="1" latinLnBrk="0" hangingPunct="1">
+      <a:defRPr sz="1200" kern="1200">
+        <a:solidFill>
+          <a:schemeClr val="tx1"/>
+        </a:solidFill>
+        <a:latin typeface="+mn-lt"/>
+        <a:ea typeface="+mn-ea"/>
+        <a:cs typeface="+mn-cs"/>
+      </a:defRPr>
+    </a:lvl5pPr>
+    <a:lvl6pPr marL="2286000" algn="l" defTabSz="914400" rtl="0" eaLnBrk="1" latinLnBrk="0" hangingPunct="1">
+      <a:defRPr sz="1200" kern="1200">
+        <a:solidFill>
+          <a:schemeClr val="tx1"/>
+        </a:solidFill>
+        <a:latin typeface="+mn-lt"/>
+        <a:ea typeface="+mn-ea"/>
+        <a:cs typeface="+mn-cs"/>
+      </a:defRPr>
+    </a:lvl6pPr>
+    <a:lvl7pPr marL="2743200" algn="l" defTabSz="914400" rtl="0" eaLnBrk="1" latinLnBrk="0" hangingPunct="1">
+      <a:defRPr sz="1200" kern="1200">
+        <a:solidFill>
+          <a:schemeClr val="tx1"/>
+        </a:solidFill>
+        <a:latin typeface="+mn-lt"/>
+        <a:ea typeface="+mn-ea"/>
+        <a:cs typeface="+mn-cs"/>
+      </a:defRPr>
+    </a:lvl7pPr>
+    <a:lvl8pPr marL="3200400" algn="l" defTabSz="914400" rtl="0" eaLnBrk="1" latinLnBrk="0" hangingPunct="1">
+      <a:defRPr sz="1200" kern="1200">
+        <a:solidFill>
+          <a:schemeClr val="tx1"/>
+        </a:solidFill>
+        <a:latin typeface="+mn-lt"/>
+        <a:ea typeface="+mn-ea"/>
+        <a:cs typeface="+mn-cs"/>
+      </a:defRPr>
+    </a:lvl8pPr>
+    <a:lvl9pPr marL="3657600" algn="l" defTabSz="914400" rtl="0" eaLnBrk="1" latinLnBrk="0" hangingPunct="1">
+      <a:defRPr sz="1200" kern="1200">
+        <a:solidFill>
+          <a:schemeClr val="tx1"/>
+        </a:solidFill>
+        <a:latin typeface="+mn-lt"/>
+        <a:ea typeface="+mn-ea"/>
+        <a:cs typeface="+mn-cs"/>
+      </a:defRPr>
+    </a:lvl9pPr>
+  </p:notesStyle>
+</p:notesMaster>
+</file>
+
+<file path=ppt/notesSlides/notesSlide1.xml><?xml version="1.0" encoding="utf-8"?>
+<p:notes xmlns:a="http://schemas.openxmlformats.org/drawingml/2006/main" xmlns:r="http://schemas.openxmlformats.org/officeDocument/2006/relationships" xmlns:p="http://schemas.openxmlformats.org/presentationml/2006/main">
+  <p:cSld>
+    <p:spTree>
+      <p:nvGrpSpPr>
+        <p:cNvPr id="1" name=""/>
+        <p:cNvGrpSpPr/>
+        <p:nvPr/>
+      </p:nvGrpSpPr>
+      <p:grpSpPr>
+        <a:xfrm>
+          <a:off x="0" y="0"/>
+          <a:ext cx="0" cy="0"/>
+          <a:chOff x="0" y="0"/>
+          <a:chExt cx="0" cy="0"/>
+        </a:xfrm>
+      </p:grpSpPr>
+      <p:sp>
+        <p:nvSpPr>
+          <p:cNvPr id="2" name="Espace réservé de l'image des diapositives 1"/>
+          <p:cNvSpPr>
+            <a:spLocks noGrp="1" noRot="1" noChangeAspect="1"/>
+          </p:cNvSpPr>
+          <p:nvPr>
+            <p:ph type="sldImg"/>
+          </p:nvPr>
+        </p:nvSpPr>
+        <p:spPr/>
+      </p:sp>
+      <p:sp>
+        <p:nvSpPr>
+          <p:cNvPr id="3" name="Espace réservé des notes 2"/>
+          <p:cNvSpPr>
+            <a:spLocks noGrp="1"/>
+          </p:cNvSpPr>
+          <p:nvPr>
+            <p:ph type="body" idx="1"/>
+          </p:nvPr>
+        </p:nvSpPr>
+        <p:spPr/>
+        <p:txBody>
+          <a:bodyPr/>
+          <a:lstStyle/>
+          <a:p>
+            <a:r>
+              <a:rPr lang="fr-FR" dirty="0"/>
+              <a:t>3,3 check</a:t>
+            </a:r>
+            <a:endParaRPr lang="en-GB" dirty="0"/>
+          </a:p>
+        </p:txBody>
+      </p:sp>
+      <p:sp>
+        <p:nvSpPr>
+          <p:cNvPr id="4" name="Espace réservé du numéro de diapositive 3"/>
+          <p:cNvSpPr>
+            <a:spLocks noGrp="1"/>
+          </p:cNvSpPr>
+          <p:nvPr>
+            <p:ph type="sldNum" sz="quarter" idx="5"/>
+          </p:nvPr>
+        </p:nvSpPr>
+        <p:spPr/>
+        <p:txBody>
+          <a:bodyPr/>
+          <a:lstStyle/>
+          <a:p>
+            <a:fld id="{7512EB12-3C52-4A5B-9741-32EF9D1D721D}" type="slidenum">
+              <a:rPr lang="en-GB" smtClean="0"/>
+              <a:t>2</a:t>
+            </a:fld>
+            <a:endParaRPr lang="en-GB"/>
+          </a:p>
+        </p:txBody>
+      </p:sp>
+    </p:spTree>
+    <p:extLst>
+      <p:ext uri="{BB962C8B-B14F-4D97-AF65-F5344CB8AC3E}">
+        <p14:creationId xmlns:p14="http://schemas.microsoft.com/office/powerpoint/2010/main" val="3166291482"/>
+      </p:ext>
+    </p:extLst>
+  </p:cSld>
+  <p:clrMapOvr>
+    <a:masterClrMapping/>
+  </p:clrMapOvr>
+</p:notes>
+</file>
+
+<file path=ppt/notesSlides/notesSlide2.xml><?xml version="1.0" encoding="utf-8"?>
+<p:notes xmlns:a="http://schemas.openxmlformats.org/drawingml/2006/main" xmlns:r="http://schemas.openxmlformats.org/officeDocument/2006/relationships" xmlns:p="http://schemas.openxmlformats.org/presentationml/2006/main">
+  <p:cSld>
+    <p:spTree>
+      <p:nvGrpSpPr>
+        <p:cNvPr id="1" name=""/>
+        <p:cNvGrpSpPr/>
+        <p:nvPr/>
+      </p:nvGrpSpPr>
+      <p:grpSpPr>
+        <a:xfrm>
+          <a:off x="0" y="0"/>
+          <a:ext cx="0" cy="0"/>
+          <a:chOff x="0" y="0"/>
+          <a:chExt cx="0" cy="0"/>
+        </a:xfrm>
+      </p:grpSpPr>
+      <p:sp>
+        <p:nvSpPr>
+          <p:cNvPr id="2" name="Espace réservé de l'image des diapositives 1"/>
+          <p:cNvSpPr>
+            <a:spLocks noGrp="1" noRot="1" noChangeAspect="1"/>
+          </p:cNvSpPr>
+          <p:nvPr>
+            <p:ph type="sldImg"/>
+          </p:nvPr>
+        </p:nvSpPr>
+        <p:spPr/>
+      </p:sp>
+      <p:sp>
+        <p:nvSpPr>
+          <p:cNvPr id="3" name="Espace réservé des notes 2"/>
+          <p:cNvSpPr>
+            <a:spLocks noGrp="1"/>
+          </p:cNvSpPr>
+          <p:nvPr>
+            <p:ph type="body" idx="1"/>
+          </p:nvPr>
+        </p:nvSpPr>
+        <p:spPr/>
+        <p:txBody>
+          <a:bodyPr/>
+          <a:lstStyle/>
+          <a:p>
+            <a:r>
+              <a:rPr lang="fr-FR" dirty="0"/>
+              <a:t>3,3 check</a:t>
+            </a:r>
+            <a:endParaRPr lang="en-GB" dirty="0"/>
+          </a:p>
+        </p:txBody>
+      </p:sp>
+      <p:sp>
+        <p:nvSpPr>
+          <p:cNvPr id="4" name="Espace réservé du numéro de diapositive 3"/>
+          <p:cNvSpPr>
+            <a:spLocks noGrp="1"/>
+          </p:cNvSpPr>
+          <p:nvPr>
+            <p:ph type="sldNum" sz="quarter" idx="5"/>
+          </p:nvPr>
+        </p:nvSpPr>
+        <p:spPr/>
+        <p:txBody>
+          <a:bodyPr/>
+          <a:lstStyle/>
+          <a:p>
+            <a:fld id="{7512EB12-3C52-4A5B-9741-32EF9D1D721D}" type="slidenum">
+              <a:rPr lang="en-GB" smtClean="0"/>
+              <a:t>3</a:t>
+            </a:fld>
+            <a:endParaRPr lang="en-GB"/>
+          </a:p>
+        </p:txBody>
+      </p:sp>
+    </p:spTree>
+    <p:extLst>
+      <p:ext uri="{BB962C8B-B14F-4D97-AF65-F5344CB8AC3E}">
+        <p14:creationId xmlns:p14="http://schemas.microsoft.com/office/powerpoint/2010/main" val="2048777989"/>
+      </p:ext>
+    </p:extLst>
+  </p:cSld>
+  <p:clrMapOvr>
+    <a:masterClrMapping/>
+  </p:clrMapOvr>
+</p:notes>
 </file>
 
 <file path=ppt/slideLayouts/slideLayout1.xml><?xml version="1.0" encoding="utf-8"?>
@@ -257,7 +793,7 @@
           <a:p>
             <a:fld id="{DCD882A2-DD72-4F80-A6AB-80BB922E5FBF}" type="datetimeFigureOut">
               <a:rPr lang="en-GB" smtClean="0"/>
-              <a:t>26/06/2020</a:t>
+              <a:t>26/09/2020</a:t>
             </a:fld>
             <a:endParaRPr lang="en-GB" dirty="0"/>
           </a:p>
@@ -457,7 +993,7 @@
           <a:p>
             <a:fld id="{DCD882A2-DD72-4F80-A6AB-80BB922E5FBF}" type="datetimeFigureOut">
               <a:rPr lang="en-GB" smtClean="0"/>
-              <a:t>26/06/2020</a:t>
+              <a:t>26/09/2020</a:t>
             </a:fld>
             <a:endParaRPr lang="en-GB" dirty="0"/>
           </a:p>
@@ -667,7 +1203,7 @@
           <a:p>
             <a:fld id="{DCD882A2-DD72-4F80-A6AB-80BB922E5FBF}" type="datetimeFigureOut">
               <a:rPr lang="en-GB" smtClean="0"/>
-              <a:t>26/06/2020</a:t>
+              <a:t>26/09/2020</a:t>
             </a:fld>
             <a:endParaRPr lang="en-GB" dirty="0"/>
           </a:p>
@@ -867,7 +1403,7 @@
           <a:p>
             <a:fld id="{DCD882A2-DD72-4F80-A6AB-80BB922E5FBF}" type="datetimeFigureOut">
               <a:rPr lang="en-GB" smtClean="0"/>
-              <a:t>26/06/2020</a:t>
+              <a:t>26/09/2020</a:t>
             </a:fld>
             <a:endParaRPr lang="en-GB" dirty="0"/>
           </a:p>
@@ -1143,7 +1679,7 @@
           <a:p>
             <a:fld id="{DCD882A2-DD72-4F80-A6AB-80BB922E5FBF}" type="datetimeFigureOut">
               <a:rPr lang="en-GB" smtClean="0"/>
-              <a:t>26/06/2020</a:t>
+              <a:t>26/09/2020</a:t>
             </a:fld>
             <a:endParaRPr lang="en-GB" dirty="0"/>
           </a:p>
@@ -1411,7 +1947,7 @@
           <a:p>
             <a:fld id="{DCD882A2-DD72-4F80-A6AB-80BB922E5FBF}" type="datetimeFigureOut">
               <a:rPr lang="en-GB" smtClean="0"/>
-              <a:t>26/06/2020</a:t>
+              <a:t>26/09/2020</a:t>
             </a:fld>
             <a:endParaRPr lang="en-GB" dirty="0"/>
           </a:p>
@@ -1826,7 +2362,7 @@
           <a:p>
             <a:fld id="{DCD882A2-DD72-4F80-A6AB-80BB922E5FBF}" type="datetimeFigureOut">
               <a:rPr lang="en-GB" smtClean="0"/>
-              <a:t>26/06/2020</a:t>
+              <a:t>26/09/2020</a:t>
             </a:fld>
             <a:endParaRPr lang="en-GB" dirty="0"/>
           </a:p>
@@ -1968,7 +2504,7 @@
           <a:p>
             <a:fld id="{DCD882A2-DD72-4F80-A6AB-80BB922E5FBF}" type="datetimeFigureOut">
               <a:rPr lang="en-GB" smtClean="0"/>
-              <a:t>26/06/2020</a:t>
+              <a:t>26/09/2020</a:t>
             </a:fld>
             <a:endParaRPr lang="en-GB" dirty="0"/>
           </a:p>
@@ -2081,7 +2617,7 @@
           <a:p>
             <a:fld id="{DCD882A2-DD72-4F80-A6AB-80BB922E5FBF}" type="datetimeFigureOut">
               <a:rPr lang="en-GB" smtClean="0"/>
-              <a:t>26/06/2020</a:t>
+              <a:t>26/09/2020</a:t>
             </a:fld>
             <a:endParaRPr lang="en-GB" dirty="0"/>
           </a:p>
@@ -2394,7 +2930,7 @@
           <a:p>
             <a:fld id="{DCD882A2-DD72-4F80-A6AB-80BB922E5FBF}" type="datetimeFigureOut">
               <a:rPr lang="en-GB" smtClean="0"/>
-              <a:t>26/06/2020</a:t>
+              <a:t>26/09/2020</a:t>
             </a:fld>
             <a:endParaRPr lang="en-GB" dirty="0"/>
           </a:p>
@@ -2683,7 +3219,7 @@
           <a:p>
             <a:fld id="{DCD882A2-DD72-4F80-A6AB-80BB922E5FBF}" type="datetimeFigureOut">
               <a:rPr lang="en-GB" smtClean="0"/>
-              <a:t>26/06/2020</a:t>
+              <a:t>26/09/2020</a:t>
             </a:fld>
             <a:endParaRPr lang="en-GB" dirty="0"/>
           </a:p>
@@ -2926,7 +3462,7 @@
           <a:p>
             <a:fld id="{DCD882A2-DD72-4F80-A6AB-80BB922E5FBF}" type="datetimeFigureOut">
               <a:rPr lang="en-GB" smtClean="0"/>
-              <a:t>26/06/2020</a:t>
+              <a:t>26/09/2020</a:t>
             </a:fld>
             <a:endParaRPr lang="en-GB" dirty="0"/>
           </a:p>
@@ -3413,6 +3949,9 @@
           <a:prstGeom prst="ellipse">
             <a:avLst/>
           </a:prstGeom>
+          <a:solidFill>
+            <a:srgbClr val="C00000"/>
+          </a:solidFill>
         </p:spPr>
         <p:style>
           <a:lnRef idx="2">
@@ -3463,6 +4002,9 @@
           <a:prstGeom prst="ellipse">
             <a:avLst/>
           </a:prstGeom>
+          <a:solidFill>
+            <a:srgbClr val="C00000"/>
+          </a:solidFill>
         </p:spPr>
         <p:style>
           <a:lnRef idx="2">
@@ -3567,7 +4109,9 @@
             <a:avLst/>
           </a:prstGeom>
           <a:solidFill>
-            <a:srgbClr val="C00000"/>
+            <a:schemeClr val="accent6">
+              <a:lumMod val="75000"/>
+            </a:schemeClr>
           </a:solidFill>
         </p:spPr>
         <p:style>
@@ -4175,8 +4719,8 @@
         </p:nvSpPr>
         <p:spPr>
           <a:xfrm rot="16200000">
-            <a:off x="360578" y="3277283"/>
-            <a:ext cx="2584747" cy="646331"/>
+            <a:off x="712377" y="3031062"/>
+            <a:ext cx="2584747" cy="1138773"/>
           </a:xfrm>
           <a:prstGeom prst="rect">
             <a:avLst/>
@@ -4199,6 +4743,15 @@
               <a:rPr lang="fr-BE" dirty="0"/>
               <a:t>s.STRAM_DATA_BLOCKED</a:t>
             </a:r>
+          </a:p>
+          <a:p>
+            <a:r>
+              <a:rPr lang="en-GB" sz="1400" dirty="0"/>
+              <a:t>Peer Create Bidirectional Stream</a:t>
+            </a:r>
+            <a:endParaRPr lang="fr-BE" sz="1400" dirty="0"/>
+          </a:p>
+          <a:p>
             <a:endParaRPr lang="en-GB" dirty="0"/>
           </a:p>
         </p:txBody>
@@ -4244,6 +4797,241 @@
           </a:fontRef>
         </p:style>
       </p:cxnSp>
+      <p:sp>
+        <p:nvSpPr>
+          <p:cNvPr id="2" name="ZoneTexte 1">
+            <a:extLst>
+              <a:ext uri="{FF2B5EF4-FFF2-40B4-BE49-F238E27FC236}">
+                <a16:creationId xmlns:a16="http://schemas.microsoft.com/office/drawing/2014/main" id="{88F6E5C9-E973-4B06-9C4B-9944C2767988}"/>
+              </a:ext>
+            </a:extLst>
+          </p:cNvPr>
+          <p:cNvSpPr txBox="1"/>
+          <p:nvPr/>
+        </p:nvSpPr>
+        <p:spPr>
+          <a:xfrm>
+            <a:off x="359650" y="436564"/>
+            <a:ext cx="3232936" cy="646331"/>
+          </a:xfrm>
+          <a:prstGeom prst="rect">
+            <a:avLst/>
+          </a:prstGeom>
+          <a:noFill/>
+        </p:spPr>
+        <p:txBody>
+          <a:bodyPr wrap="none" rtlCol="0">
+            <a:spAutoFit/>
+          </a:bodyPr>
+          <a:lstStyle/>
+          <a:p>
+            <a:r>
+              <a:rPr lang="fr-BE" dirty="0"/>
+              <a:t>Create Stream (Sending</a:t>
+            </a:r>
+            <a:r>
+              <a:rPr lang="en-GB" dirty="0"/>
+              <a:t>)</a:t>
+            </a:r>
+          </a:p>
+          <a:p>
+            <a:r>
+              <a:rPr lang="en-GB" dirty="0"/>
+              <a:t>Peer Create Bidirectional Stream</a:t>
+            </a:r>
+            <a:endParaRPr lang="fr-BE" dirty="0"/>
+          </a:p>
+        </p:txBody>
+      </p:sp>
+      <p:sp>
+        <p:nvSpPr>
+          <p:cNvPr id="3" name="Bulle narrative : rectangle à coins arrondis 2">
+            <a:extLst>
+              <a:ext uri="{FF2B5EF4-FFF2-40B4-BE49-F238E27FC236}">
+                <a16:creationId xmlns:a16="http://schemas.microsoft.com/office/drawing/2014/main" id="{988D0EB4-947A-46B9-A29D-46DAE79C5B8E}"/>
+              </a:ext>
+            </a:extLst>
+          </p:cNvPr>
+          <p:cNvSpPr/>
+          <p:nvPr/>
+        </p:nvSpPr>
+        <p:spPr>
+          <a:xfrm>
+            <a:off x="3790358" y="1072421"/>
+            <a:ext cx="1126921" cy="369332"/>
+          </a:xfrm>
+          <a:prstGeom prst="wedgeRoundRectCallout">
+            <a:avLst/>
+          </a:prstGeom>
+          <a:ln>
+            <a:solidFill>
+              <a:schemeClr val="tx1"/>
+            </a:solidFill>
+          </a:ln>
+        </p:spPr>
+        <p:style>
+          <a:lnRef idx="2">
+            <a:schemeClr val="accent6"/>
+          </a:lnRef>
+          <a:fillRef idx="1">
+            <a:schemeClr val="lt1"/>
+          </a:fillRef>
+          <a:effectRef idx="0">
+            <a:schemeClr val="accent6"/>
+          </a:effectRef>
+          <a:fontRef idx="minor">
+            <a:schemeClr val="dk1"/>
+          </a:fontRef>
+        </p:style>
+        <p:txBody>
+          <a:bodyPr rtlCol="0" anchor="ctr"/>
+          <a:lstStyle/>
+          <a:p>
+            <a:pPr algn="ctr"/>
+            <a:r>
+              <a:rPr lang="fr-FR" dirty="0"/>
+              <a:t>sending</a:t>
+            </a:r>
+            <a:endParaRPr lang="en-GB" dirty="0"/>
+          </a:p>
+        </p:txBody>
+      </p:sp>
+      <p:sp>
+        <p:nvSpPr>
+          <p:cNvPr id="10" name="Bulle narrative : rectangle à coins arrondis 9">
+            <a:extLst>
+              <a:ext uri="{FF2B5EF4-FFF2-40B4-BE49-F238E27FC236}">
+                <a16:creationId xmlns:a16="http://schemas.microsoft.com/office/drawing/2014/main" id="{5DD2B065-1291-4E98-9EA8-E397CA6004D6}"/>
+              </a:ext>
+            </a:extLst>
+          </p:cNvPr>
+          <p:cNvSpPr/>
+          <p:nvPr/>
+        </p:nvSpPr>
+        <p:spPr>
+          <a:xfrm>
+            <a:off x="7599222" y="1138519"/>
+            <a:ext cx="1126921" cy="369332"/>
+          </a:xfrm>
+          <a:prstGeom prst="wedgeRoundRectCallout">
+            <a:avLst/>
+          </a:prstGeom>
+          <a:ln>
+            <a:solidFill>
+              <a:schemeClr val="tx1"/>
+            </a:solidFill>
+          </a:ln>
+        </p:spPr>
+        <p:style>
+          <a:lnRef idx="2">
+            <a:schemeClr val="accent6"/>
+          </a:lnRef>
+          <a:fillRef idx="1">
+            <a:schemeClr val="lt1"/>
+          </a:fillRef>
+          <a:effectRef idx="0">
+            <a:schemeClr val="accent6"/>
+          </a:effectRef>
+          <a:fontRef idx="minor">
+            <a:schemeClr val="dk1"/>
+          </a:fontRef>
+        </p:style>
+        <p:txBody>
+          <a:bodyPr rtlCol="0" anchor="ctr"/>
+          <a:lstStyle/>
+          <a:p>
+            <a:pPr algn="ctr"/>
+            <a:r>
+              <a:rPr lang="fr-FR" dirty="0"/>
+              <a:t>receiving</a:t>
+            </a:r>
+            <a:endParaRPr lang="en-GB" dirty="0"/>
+          </a:p>
+        </p:txBody>
+      </p:sp>
+      <p:sp>
+        <p:nvSpPr>
+          <p:cNvPr id="14" name="Bulle narrative : rectangle à coins arrondis 13">
+            <a:extLst>
+              <a:ext uri="{FF2B5EF4-FFF2-40B4-BE49-F238E27FC236}">
+                <a16:creationId xmlns:a16="http://schemas.microsoft.com/office/drawing/2014/main" id="{949E7391-F356-4A29-822D-BB2783A50072}"/>
+              </a:ext>
+            </a:extLst>
+          </p:cNvPr>
+          <p:cNvSpPr/>
+          <p:nvPr/>
+        </p:nvSpPr>
+        <p:spPr>
+          <a:xfrm>
+            <a:off x="9228239" y="624253"/>
+            <a:ext cx="1126921" cy="603783"/>
+          </a:xfrm>
+          <a:prstGeom prst="wedgeRoundRectCallout">
+            <a:avLst/>
+          </a:prstGeom>
+        </p:spPr>
+        <p:style>
+          <a:lnRef idx="2">
+            <a:schemeClr val="accent6"/>
+          </a:lnRef>
+          <a:fillRef idx="1">
+            <a:schemeClr val="lt1"/>
+          </a:fillRef>
+          <a:effectRef idx="0">
+            <a:schemeClr val="accent6"/>
+          </a:effectRef>
+          <a:fontRef idx="minor">
+            <a:schemeClr val="dk1"/>
+          </a:fontRef>
+        </p:style>
+        <p:txBody>
+          <a:bodyPr rtlCol="0" anchor="ctr"/>
+          <a:lstStyle/>
+          <a:p>
+            <a:pPr algn="ctr"/>
+            <a:r>
+              <a:rPr lang="fr-FR" dirty="0"/>
+              <a:t>Terminal state</a:t>
+            </a:r>
+            <a:endParaRPr lang="en-GB" dirty="0"/>
+          </a:p>
+        </p:txBody>
+      </p:sp>
+      <p:sp>
+        <p:nvSpPr>
+          <p:cNvPr id="32" name="ZoneTexte 31">
+            <a:extLst>
+              <a:ext uri="{FF2B5EF4-FFF2-40B4-BE49-F238E27FC236}">
+                <a16:creationId xmlns:a16="http://schemas.microsoft.com/office/drawing/2014/main" id="{3854FA4F-3B96-4A8F-9412-672862F5CD0D}"/>
+              </a:ext>
+            </a:extLst>
+          </p:cNvPr>
+          <p:cNvSpPr txBox="1"/>
+          <p:nvPr/>
+        </p:nvSpPr>
+        <p:spPr>
+          <a:xfrm>
+            <a:off x="3851075" y="-11029"/>
+            <a:ext cx="3985757" cy="523220"/>
+          </a:xfrm>
+          <a:prstGeom prst="rect">
+            <a:avLst/>
+          </a:prstGeom>
+          <a:noFill/>
+        </p:spPr>
+        <p:txBody>
+          <a:bodyPr wrap="square">
+            <a:spAutoFit/>
+          </a:bodyPr>
+          <a:lstStyle/>
+          <a:p>
+            <a:r>
+              <a:rPr lang="en-GB" sz="2800" b="1" dirty="0"/>
+              <a:t>Sending Stream States</a:t>
+            </a:r>
+          </a:p>
+        </p:txBody>
+      </p:sp>
     </p:spTree>
     <p:extLst>
       <p:ext uri="{BB962C8B-B14F-4D97-AF65-F5344CB8AC3E}">
@@ -4344,6 +5132,9 @@
           <a:prstGeom prst="ellipse">
             <a:avLst/>
           </a:prstGeom>
+          <a:solidFill>
+            <a:srgbClr val="C00000"/>
+          </a:solidFill>
         </p:spPr>
         <p:style>
           <a:lnRef idx="2">
@@ -4388,12 +5179,15 @@
         </p:nvSpPr>
         <p:spPr>
           <a:xfrm>
-            <a:off x="5348653" y="4897317"/>
+            <a:off x="5348652" y="4897315"/>
             <a:ext cx="1494693" cy="931985"/>
           </a:xfrm>
           <a:prstGeom prst="ellipse">
             <a:avLst/>
           </a:prstGeom>
+          <a:solidFill>
+            <a:srgbClr val="C00000"/>
+          </a:solidFill>
         </p:spPr>
         <p:style>
           <a:lnRef idx="2">
@@ -4498,7 +5292,9 @@
             <a:avLst/>
           </a:prstGeom>
           <a:solidFill>
-            <a:srgbClr val="C00000"/>
+            <a:schemeClr val="accent6">
+              <a:lumMod val="75000"/>
+            </a:schemeClr>
           </a:solidFill>
         </p:spPr>
         <p:style>
@@ -4579,7 +5375,7 @@
             <a:pPr algn="ctr"/>
             <a:r>
               <a:rPr lang="fr-BE" b="1" dirty="0"/>
-              <a:t>Data Recvd </a:t>
+              <a:t>Data Read </a:t>
             </a:r>
             <a:endParaRPr lang="en-GB" b="1" dirty="0"/>
           </a:p>
@@ -4724,9 +5520,9 @@
           <p:nvPr/>
         </p:nvCxnSpPr>
         <p:spPr>
-          <a:xfrm>
-            <a:off x="3147645" y="5363310"/>
-            <a:ext cx="2201008" cy="0"/>
+          <a:xfrm flipV="1">
+            <a:off x="3147645" y="5363308"/>
+            <a:ext cx="2201007" cy="2"/>
           </a:xfrm>
           <a:prstGeom prst="straightConnector1">
             <a:avLst/>
@@ -4766,9 +5562,9 @@
           <p:nvPr/>
         </p:nvCxnSpPr>
         <p:spPr>
-          <a:xfrm flipV="1">
-            <a:off x="6843346" y="5363309"/>
-            <a:ext cx="2201008" cy="1"/>
+          <a:xfrm>
+            <a:off x="6843345" y="5363308"/>
+            <a:ext cx="2201009" cy="1"/>
           </a:xfrm>
           <a:prstGeom prst="straightConnector1">
             <a:avLst/>
@@ -5181,8 +5977,8 @@
         </p:nvSpPr>
         <p:spPr>
           <a:xfrm>
-            <a:off x="1472254" y="540684"/>
-            <a:ext cx="4012317" cy="923330"/>
+            <a:off x="229185" y="14804"/>
+            <a:ext cx="5386283" cy="1200329"/>
           </a:xfrm>
           <a:prstGeom prst="rect">
             <a:avLst/>
@@ -5197,19 +5993,25 @@
           <a:p>
             <a:r>
               <a:rPr lang="fr-BE" dirty="0"/>
-              <a:t>r.STREAM / r.RESET_STREAM</a:t>
+              <a:t>r.STREAM / r.RESET_STREAM/ r.STRAM_DATA_BLOCKED</a:t>
             </a:r>
           </a:p>
           <a:p>
             <a:r>
               <a:rPr lang="fr-BE" dirty="0"/>
-              <a:t>r.STRAM_DATA_BLOCKED</a:t>
+              <a:t>Create Bidirectional Stream (Sending)</a:t>
             </a:r>
           </a:p>
           <a:p>
             <a:r>
               <a:rPr lang="fr-BE" dirty="0"/>
-              <a:t>r.MAX_STREAM_DATA / r.STOP_SENDING</a:t>
+              <a:t>r.MAX_STREAM_DATA / r.STOP_SENDING (Bidirectional)</a:t>
+            </a:r>
+          </a:p>
+          <a:p>
+            <a:r>
+              <a:rPr lang="fr-BE" dirty="0"/>
+              <a:t>Create Higher-Numbered Stream</a:t>
             </a:r>
             <a:endParaRPr lang="en-GB" dirty="0"/>
           </a:p>
@@ -5292,10 +6094,2312 @@
           </a:p>
         </p:txBody>
       </p:sp>
+      <p:sp>
+        <p:nvSpPr>
+          <p:cNvPr id="18" name="ZoneTexte 17">
+            <a:extLst>
+              <a:ext uri="{FF2B5EF4-FFF2-40B4-BE49-F238E27FC236}">
+                <a16:creationId xmlns:a16="http://schemas.microsoft.com/office/drawing/2014/main" id="{1B9DEA2C-3E1F-47F7-9854-33FFAE313979}"/>
+              </a:ext>
+            </a:extLst>
+          </p:cNvPr>
+          <p:cNvSpPr txBox="1"/>
+          <p:nvPr/>
+        </p:nvSpPr>
+        <p:spPr>
+          <a:xfrm>
+            <a:off x="6117824" y="19667"/>
+            <a:ext cx="3985757" cy="523220"/>
+          </a:xfrm>
+          <a:prstGeom prst="rect">
+            <a:avLst/>
+          </a:prstGeom>
+          <a:noFill/>
+        </p:spPr>
+        <p:txBody>
+          <a:bodyPr wrap="square">
+            <a:spAutoFit/>
+          </a:bodyPr>
+          <a:lstStyle/>
+          <a:p>
+            <a:r>
+              <a:rPr lang="en-GB" sz="2800" b="1" dirty="0"/>
+              <a:t>Receiving Stream States</a:t>
+            </a:r>
+          </a:p>
+        </p:txBody>
+      </p:sp>
     </p:spTree>
     <p:extLst>
       <p:ext uri="{BB962C8B-B14F-4D97-AF65-F5344CB8AC3E}">
         <p14:creationId xmlns:p14="http://schemas.microsoft.com/office/powerpoint/2010/main" val="1520386991"/>
+      </p:ext>
+    </p:extLst>
+  </p:cSld>
+  <p:clrMapOvr>
+    <a:masterClrMapping/>
+  </p:clrMapOvr>
+</p:sld>
+</file>
+
+<file path=ppt/slides/slide3.xml><?xml version="1.0" encoding="utf-8"?>
+<p:sld xmlns:a="http://schemas.openxmlformats.org/drawingml/2006/main" xmlns:r="http://schemas.openxmlformats.org/officeDocument/2006/relationships" xmlns:p="http://schemas.openxmlformats.org/presentationml/2006/main">
+  <p:cSld>
+    <p:spTree>
+      <p:nvGrpSpPr>
+        <p:cNvPr id="1" name=""/>
+        <p:cNvGrpSpPr/>
+        <p:nvPr/>
+      </p:nvGrpSpPr>
+      <p:grpSpPr>
+        <a:xfrm>
+          <a:off x="0" y="0"/>
+          <a:ext cx="0" cy="0"/>
+          <a:chOff x="0" y="0"/>
+          <a:chExt cx="0" cy="0"/>
+        </a:xfrm>
+      </p:grpSpPr>
+      <p:sp>
+        <p:nvSpPr>
+          <p:cNvPr id="162" name="ZoneTexte 161">
+            <a:extLst>
+              <a:ext uri="{FF2B5EF4-FFF2-40B4-BE49-F238E27FC236}">
+                <a16:creationId xmlns:a16="http://schemas.microsoft.com/office/drawing/2014/main" id="{1E9F2AA7-EE6F-4583-B9CC-274E91DD8329}"/>
+              </a:ext>
+            </a:extLst>
+          </p:cNvPr>
+          <p:cNvSpPr txBox="1"/>
+          <p:nvPr/>
+        </p:nvSpPr>
+        <p:spPr>
+          <a:xfrm>
+            <a:off x="3851075" y="-11029"/>
+            <a:ext cx="4273838" cy="523220"/>
+          </a:xfrm>
+          <a:prstGeom prst="rect">
+            <a:avLst/>
+          </a:prstGeom>
+          <a:noFill/>
+        </p:spPr>
+        <p:txBody>
+          <a:bodyPr wrap="square">
+            <a:spAutoFit/>
+          </a:bodyPr>
+          <a:lstStyle/>
+          <a:p>
+            <a:r>
+              <a:rPr lang="en-GB" sz="2800" b="1" dirty="0"/>
+              <a:t>Bidirectional Stream States</a:t>
+            </a:r>
+          </a:p>
+        </p:txBody>
+      </p:sp>
+      <p:sp>
+        <p:nvSpPr>
+          <p:cNvPr id="164" name="Ellipse 163">
+            <a:extLst>
+              <a:ext uri="{FF2B5EF4-FFF2-40B4-BE49-F238E27FC236}">
+                <a16:creationId xmlns:a16="http://schemas.microsoft.com/office/drawing/2014/main" id="{1EA6948B-714F-43F0-9744-118D43364489}"/>
+              </a:ext>
+            </a:extLst>
+          </p:cNvPr>
+          <p:cNvSpPr/>
+          <p:nvPr/>
+        </p:nvSpPr>
+        <p:spPr>
+          <a:xfrm>
+            <a:off x="1114692" y="329113"/>
+            <a:ext cx="1632113" cy="728460"/>
+          </a:xfrm>
+          <a:prstGeom prst="ellipse">
+            <a:avLst/>
+          </a:prstGeom>
+        </p:spPr>
+        <p:style>
+          <a:lnRef idx="2">
+            <a:schemeClr val="accent5">
+              <a:shade val="50000"/>
+            </a:schemeClr>
+          </a:lnRef>
+          <a:fillRef idx="1">
+            <a:schemeClr val="accent5"/>
+          </a:fillRef>
+          <a:effectRef idx="0">
+            <a:schemeClr val="accent5"/>
+          </a:effectRef>
+          <a:fontRef idx="minor">
+            <a:schemeClr val="lt1"/>
+          </a:fontRef>
+        </p:style>
+        <p:txBody>
+          <a:bodyPr rtlCol="0" anchor="ctr"/>
+          <a:lstStyle/>
+          <a:p>
+            <a:pPr algn="ctr"/>
+            <a:r>
+              <a:rPr lang="fr-BE" sz="1600" b="1" dirty="0" err="1"/>
+              <a:t>idle</a:t>
+            </a:r>
+            <a:r>
+              <a:rPr lang="fr-BE" sz="1600" b="1" dirty="0"/>
+              <a:t> </a:t>
+            </a:r>
+            <a:endParaRPr lang="en-GB" sz="1600" b="1" dirty="0"/>
+          </a:p>
+        </p:txBody>
+      </p:sp>
+      <p:sp>
+        <p:nvSpPr>
+          <p:cNvPr id="168" name="Ellipse 167">
+            <a:extLst>
+              <a:ext uri="{FF2B5EF4-FFF2-40B4-BE49-F238E27FC236}">
+                <a16:creationId xmlns:a16="http://schemas.microsoft.com/office/drawing/2014/main" id="{CB6D624A-7107-465A-8446-21A7AFD83649}"/>
+              </a:ext>
+            </a:extLst>
+          </p:cNvPr>
+          <p:cNvSpPr/>
+          <p:nvPr/>
+        </p:nvSpPr>
+        <p:spPr>
+          <a:xfrm>
+            <a:off x="1114692" y="2916149"/>
+            <a:ext cx="1632113" cy="728460"/>
+          </a:xfrm>
+          <a:prstGeom prst="ellipse">
+            <a:avLst/>
+          </a:prstGeom>
+        </p:spPr>
+        <p:style>
+          <a:lnRef idx="2">
+            <a:schemeClr val="accent5">
+              <a:shade val="50000"/>
+            </a:schemeClr>
+          </a:lnRef>
+          <a:fillRef idx="1">
+            <a:schemeClr val="accent5"/>
+          </a:fillRef>
+          <a:effectRef idx="0">
+            <a:schemeClr val="accent5"/>
+          </a:effectRef>
+          <a:fontRef idx="minor">
+            <a:schemeClr val="lt1"/>
+          </a:fontRef>
+        </p:style>
+        <p:txBody>
+          <a:bodyPr rtlCol="0" anchor="ctr"/>
+          <a:lstStyle/>
+          <a:p>
+            <a:pPr algn="ctr"/>
+            <a:r>
+              <a:rPr lang="fr-BE" sz="1600" b="1" dirty="0"/>
+              <a:t>Open </a:t>
+            </a:r>
+            <a:endParaRPr lang="en-GB" sz="1600" b="1" dirty="0"/>
+          </a:p>
+        </p:txBody>
+      </p:sp>
+      <p:sp>
+        <p:nvSpPr>
+          <p:cNvPr id="170" name="Ellipse 169">
+            <a:extLst>
+              <a:ext uri="{FF2B5EF4-FFF2-40B4-BE49-F238E27FC236}">
+                <a16:creationId xmlns:a16="http://schemas.microsoft.com/office/drawing/2014/main" id="{D96BE0B3-B7D3-43C3-BCE3-CF021A5D7237}"/>
+              </a:ext>
+            </a:extLst>
+          </p:cNvPr>
+          <p:cNvSpPr/>
+          <p:nvPr/>
+        </p:nvSpPr>
+        <p:spPr>
+          <a:xfrm>
+            <a:off x="7422276" y="4234674"/>
+            <a:ext cx="1632113" cy="728460"/>
+          </a:xfrm>
+          <a:prstGeom prst="ellipse">
+            <a:avLst/>
+          </a:prstGeom>
+        </p:spPr>
+        <p:style>
+          <a:lnRef idx="2">
+            <a:schemeClr val="accent5">
+              <a:shade val="50000"/>
+            </a:schemeClr>
+          </a:lnRef>
+          <a:fillRef idx="1">
+            <a:schemeClr val="accent5"/>
+          </a:fillRef>
+          <a:effectRef idx="0">
+            <a:schemeClr val="accent5"/>
+          </a:effectRef>
+          <a:fontRef idx="minor">
+            <a:schemeClr val="lt1"/>
+          </a:fontRef>
+        </p:style>
+        <p:txBody>
+          <a:bodyPr rtlCol="0" anchor="ctr"/>
+          <a:lstStyle/>
+          <a:p>
+            <a:pPr algn="ctr"/>
+            <a:r>
+              <a:rPr lang="fr-BE" sz="1600" b="1" dirty="0"/>
+              <a:t>Half-</a:t>
+            </a:r>
+            <a:r>
+              <a:rPr lang="fr-BE" sz="1600" b="1" dirty="0" err="1"/>
+              <a:t>Closed</a:t>
+            </a:r>
+            <a:endParaRPr lang="fr-BE" sz="1600" b="1" dirty="0"/>
+          </a:p>
+          <a:p>
+            <a:pPr algn="ctr"/>
+            <a:r>
+              <a:rPr lang="fr-BE" sz="1600" b="1" dirty="0"/>
+              <a:t>(</a:t>
+            </a:r>
+            <a:r>
+              <a:rPr lang="fr-BE" sz="1600" b="1" dirty="0" err="1"/>
+              <a:t>remote</a:t>
+            </a:r>
+            <a:r>
+              <a:rPr lang="fr-BE" sz="1600" b="1" dirty="0"/>
+              <a:t>)</a:t>
+            </a:r>
+            <a:endParaRPr lang="en-GB" sz="1600" b="1" dirty="0"/>
+          </a:p>
+        </p:txBody>
+      </p:sp>
+      <p:sp>
+        <p:nvSpPr>
+          <p:cNvPr id="172" name="Ellipse 171">
+            <a:extLst>
+              <a:ext uri="{FF2B5EF4-FFF2-40B4-BE49-F238E27FC236}">
+                <a16:creationId xmlns:a16="http://schemas.microsoft.com/office/drawing/2014/main" id="{619E1E41-588A-483E-9D50-84EBFE3C6057}"/>
+              </a:ext>
+            </a:extLst>
+          </p:cNvPr>
+          <p:cNvSpPr/>
+          <p:nvPr/>
+        </p:nvSpPr>
+        <p:spPr>
+          <a:xfrm>
+            <a:off x="5279943" y="3443520"/>
+            <a:ext cx="1632113" cy="728460"/>
+          </a:xfrm>
+          <a:prstGeom prst="ellipse">
+            <a:avLst/>
+          </a:prstGeom>
+        </p:spPr>
+        <p:style>
+          <a:lnRef idx="2">
+            <a:schemeClr val="accent5">
+              <a:shade val="50000"/>
+            </a:schemeClr>
+          </a:lnRef>
+          <a:fillRef idx="1">
+            <a:schemeClr val="accent5"/>
+          </a:fillRef>
+          <a:effectRef idx="0">
+            <a:schemeClr val="accent5"/>
+          </a:effectRef>
+          <a:fontRef idx="minor">
+            <a:schemeClr val="lt1"/>
+          </a:fontRef>
+        </p:style>
+        <p:txBody>
+          <a:bodyPr rtlCol="0" anchor="ctr"/>
+          <a:lstStyle/>
+          <a:p>
+            <a:pPr algn="ctr"/>
+            <a:r>
+              <a:rPr lang="fr-BE" sz="1600" b="1" dirty="0"/>
+              <a:t>Half-</a:t>
+            </a:r>
+            <a:r>
+              <a:rPr lang="fr-BE" sz="1600" b="1" dirty="0" err="1"/>
+              <a:t>Closed</a:t>
+            </a:r>
+            <a:endParaRPr lang="fr-BE" sz="1600" b="1" dirty="0"/>
+          </a:p>
+          <a:p>
+            <a:pPr algn="ctr"/>
+            <a:r>
+              <a:rPr lang="fr-BE" sz="1600" b="1" dirty="0"/>
+              <a:t>(local)</a:t>
+            </a:r>
+            <a:endParaRPr lang="en-GB" sz="1600" b="1" dirty="0"/>
+          </a:p>
+        </p:txBody>
+      </p:sp>
+      <p:sp>
+        <p:nvSpPr>
+          <p:cNvPr id="174" name="Ellipse 173">
+            <a:extLst>
+              <a:ext uri="{FF2B5EF4-FFF2-40B4-BE49-F238E27FC236}">
+                <a16:creationId xmlns:a16="http://schemas.microsoft.com/office/drawing/2014/main" id="{C5D5C692-6E58-4BC9-8D5E-89B457F0E824}"/>
+              </a:ext>
+            </a:extLst>
+          </p:cNvPr>
+          <p:cNvSpPr/>
+          <p:nvPr/>
+        </p:nvSpPr>
+        <p:spPr>
+          <a:xfrm>
+            <a:off x="9601200" y="3080071"/>
+            <a:ext cx="1632113" cy="728460"/>
+          </a:xfrm>
+          <a:prstGeom prst="ellipse">
+            <a:avLst/>
+          </a:prstGeom>
+        </p:spPr>
+        <p:style>
+          <a:lnRef idx="2">
+            <a:schemeClr val="accent5">
+              <a:shade val="50000"/>
+            </a:schemeClr>
+          </a:lnRef>
+          <a:fillRef idx="1">
+            <a:schemeClr val="accent5"/>
+          </a:fillRef>
+          <a:effectRef idx="0">
+            <a:schemeClr val="accent5"/>
+          </a:effectRef>
+          <a:fontRef idx="minor">
+            <a:schemeClr val="lt1"/>
+          </a:fontRef>
+        </p:style>
+        <p:txBody>
+          <a:bodyPr rtlCol="0" anchor="ctr"/>
+          <a:lstStyle/>
+          <a:p>
+            <a:pPr algn="ctr"/>
+            <a:r>
+              <a:rPr lang="fr-BE" sz="1600" b="1" dirty="0" err="1"/>
+              <a:t>Closed</a:t>
+            </a:r>
+            <a:endParaRPr lang="en-GB" sz="1600" b="1" dirty="0"/>
+          </a:p>
+        </p:txBody>
+      </p:sp>
+      <p:sp>
+        <p:nvSpPr>
+          <p:cNvPr id="175" name="Rectangle 174">
+            <a:extLst>
+              <a:ext uri="{FF2B5EF4-FFF2-40B4-BE49-F238E27FC236}">
+                <a16:creationId xmlns:a16="http://schemas.microsoft.com/office/drawing/2014/main" id="{66718011-F1A9-4A80-9F56-C0593A608762}"/>
+              </a:ext>
+            </a:extLst>
+          </p:cNvPr>
+          <p:cNvSpPr/>
+          <p:nvPr/>
+        </p:nvSpPr>
+        <p:spPr>
+          <a:xfrm>
+            <a:off x="313267" y="1573810"/>
+            <a:ext cx="1337733" cy="523281"/>
+          </a:xfrm>
+          <a:prstGeom prst="rect">
+            <a:avLst/>
+          </a:prstGeom>
+        </p:spPr>
+        <p:style>
+          <a:lnRef idx="2">
+            <a:schemeClr val="accent2">
+              <a:shade val="50000"/>
+            </a:schemeClr>
+          </a:lnRef>
+          <a:fillRef idx="1">
+            <a:schemeClr val="accent2"/>
+          </a:fillRef>
+          <a:effectRef idx="0">
+            <a:schemeClr val="accent2"/>
+          </a:effectRef>
+          <a:fontRef idx="minor">
+            <a:schemeClr val="lt1"/>
+          </a:fontRef>
+        </p:style>
+        <p:txBody>
+          <a:bodyPr rtlCol="0" anchor="ctr"/>
+          <a:lstStyle/>
+          <a:p>
+            <a:pPr algn="ctr"/>
+            <a:r>
+              <a:rPr lang="fr-FR" dirty="0" err="1"/>
+              <a:t>Ready</a:t>
+            </a:r>
+            <a:endParaRPr lang="en-GB" dirty="0"/>
+          </a:p>
+        </p:txBody>
+      </p:sp>
+      <p:sp>
+        <p:nvSpPr>
+          <p:cNvPr id="176" name="Rectangle : coins arrondis 175">
+            <a:extLst>
+              <a:ext uri="{FF2B5EF4-FFF2-40B4-BE49-F238E27FC236}">
+                <a16:creationId xmlns:a16="http://schemas.microsoft.com/office/drawing/2014/main" id="{6EC3BE33-2D16-45B4-B62D-63EB4C274A25}"/>
+              </a:ext>
+            </a:extLst>
+          </p:cNvPr>
+          <p:cNvSpPr/>
+          <p:nvPr/>
+        </p:nvSpPr>
+        <p:spPr>
+          <a:xfrm>
+            <a:off x="2218267" y="1557332"/>
+            <a:ext cx="1243342" cy="523220"/>
+          </a:xfrm>
+          <a:prstGeom prst="roundRect">
+            <a:avLst/>
+          </a:prstGeom>
+        </p:spPr>
+        <p:style>
+          <a:lnRef idx="2">
+            <a:schemeClr val="accent2">
+              <a:shade val="50000"/>
+            </a:schemeClr>
+          </a:lnRef>
+          <a:fillRef idx="1">
+            <a:schemeClr val="accent2"/>
+          </a:fillRef>
+          <a:effectRef idx="0">
+            <a:schemeClr val="accent2"/>
+          </a:effectRef>
+          <a:fontRef idx="minor">
+            <a:schemeClr val="lt1"/>
+          </a:fontRef>
+        </p:style>
+        <p:txBody>
+          <a:bodyPr rtlCol="0" anchor="ctr"/>
+          <a:lstStyle/>
+          <a:p>
+            <a:pPr algn="ctr"/>
+            <a:r>
+              <a:rPr lang="fr-FR" dirty="0" err="1"/>
+              <a:t>Recv</a:t>
+            </a:r>
+            <a:endParaRPr lang="en-GB" dirty="0"/>
+          </a:p>
+        </p:txBody>
+      </p:sp>
+      <p:sp>
+        <p:nvSpPr>
+          <p:cNvPr id="178" name="Rectangle 177">
+            <a:extLst>
+              <a:ext uri="{FF2B5EF4-FFF2-40B4-BE49-F238E27FC236}">
+                <a16:creationId xmlns:a16="http://schemas.microsoft.com/office/drawing/2014/main" id="{523D3E57-D6CD-47B5-9604-315199251AF9}"/>
+              </a:ext>
+            </a:extLst>
+          </p:cNvPr>
+          <p:cNvSpPr/>
+          <p:nvPr/>
+        </p:nvSpPr>
+        <p:spPr>
+          <a:xfrm>
+            <a:off x="313267" y="5093501"/>
+            <a:ext cx="1337733" cy="523281"/>
+          </a:xfrm>
+          <a:prstGeom prst="rect">
+            <a:avLst/>
+          </a:prstGeom>
+          <a:solidFill>
+            <a:srgbClr val="C00000"/>
+          </a:solidFill>
+        </p:spPr>
+        <p:style>
+          <a:lnRef idx="2">
+            <a:schemeClr val="accent2">
+              <a:shade val="50000"/>
+            </a:schemeClr>
+          </a:lnRef>
+          <a:fillRef idx="1">
+            <a:schemeClr val="accent2"/>
+          </a:fillRef>
+          <a:effectRef idx="0">
+            <a:schemeClr val="accent2"/>
+          </a:effectRef>
+          <a:fontRef idx="minor">
+            <a:schemeClr val="lt1"/>
+          </a:fontRef>
+        </p:style>
+        <p:txBody>
+          <a:bodyPr rtlCol="0" anchor="ctr"/>
+          <a:lstStyle/>
+          <a:p>
+            <a:pPr algn="ctr"/>
+            <a:r>
+              <a:rPr lang="fr-FR" dirty="0" err="1"/>
+              <a:t>Send</a:t>
+            </a:r>
+            <a:endParaRPr lang="en-GB" dirty="0"/>
+          </a:p>
+        </p:txBody>
+      </p:sp>
+      <p:sp>
+        <p:nvSpPr>
+          <p:cNvPr id="180" name="Rectangle 179">
+            <a:extLst>
+              <a:ext uri="{FF2B5EF4-FFF2-40B4-BE49-F238E27FC236}">
+                <a16:creationId xmlns:a16="http://schemas.microsoft.com/office/drawing/2014/main" id="{2357F8A8-5CDA-4D11-8FE0-1989EE191E4A}"/>
+              </a:ext>
+            </a:extLst>
+          </p:cNvPr>
+          <p:cNvSpPr/>
+          <p:nvPr/>
+        </p:nvSpPr>
+        <p:spPr>
+          <a:xfrm>
+            <a:off x="2270671" y="4598904"/>
+            <a:ext cx="1337733" cy="523281"/>
+          </a:xfrm>
+          <a:prstGeom prst="rect">
+            <a:avLst/>
+          </a:prstGeom>
+          <a:solidFill>
+            <a:srgbClr val="C00000"/>
+          </a:solidFill>
+        </p:spPr>
+        <p:style>
+          <a:lnRef idx="2">
+            <a:schemeClr val="accent2">
+              <a:shade val="50000"/>
+            </a:schemeClr>
+          </a:lnRef>
+          <a:fillRef idx="1">
+            <a:schemeClr val="accent2"/>
+          </a:fillRef>
+          <a:effectRef idx="0">
+            <a:schemeClr val="accent2"/>
+          </a:effectRef>
+          <a:fontRef idx="minor">
+            <a:schemeClr val="lt1"/>
+          </a:fontRef>
+        </p:style>
+        <p:txBody>
+          <a:bodyPr rtlCol="0" anchor="ctr"/>
+          <a:lstStyle/>
+          <a:p>
+            <a:pPr algn="ctr"/>
+            <a:r>
+              <a:rPr lang="fr-FR" dirty="0"/>
+              <a:t>Reset Sent</a:t>
+            </a:r>
+            <a:endParaRPr lang="en-GB" dirty="0"/>
+          </a:p>
+        </p:txBody>
+      </p:sp>
+      <p:sp>
+        <p:nvSpPr>
+          <p:cNvPr id="182" name="Rectangle 181">
+            <a:extLst>
+              <a:ext uri="{FF2B5EF4-FFF2-40B4-BE49-F238E27FC236}">
+                <a16:creationId xmlns:a16="http://schemas.microsoft.com/office/drawing/2014/main" id="{D725C38A-8727-4AD5-B8C6-AA47886C28D2}"/>
+              </a:ext>
+            </a:extLst>
+          </p:cNvPr>
+          <p:cNvSpPr/>
+          <p:nvPr/>
+        </p:nvSpPr>
+        <p:spPr>
+          <a:xfrm>
+            <a:off x="2270671" y="5645466"/>
+            <a:ext cx="1337733" cy="523281"/>
+          </a:xfrm>
+          <a:prstGeom prst="rect">
+            <a:avLst/>
+          </a:prstGeom>
+          <a:solidFill>
+            <a:srgbClr val="C00000"/>
+          </a:solidFill>
+        </p:spPr>
+        <p:style>
+          <a:lnRef idx="2">
+            <a:schemeClr val="accent2">
+              <a:shade val="50000"/>
+            </a:schemeClr>
+          </a:lnRef>
+          <a:fillRef idx="1">
+            <a:schemeClr val="accent2"/>
+          </a:fillRef>
+          <a:effectRef idx="0">
+            <a:schemeClr val="accent2"/>
+          </a:effectRef>
+          <a:fontRef idx="minor">
+            <a:schemeClr val="lt1"/>
+          </a:fontRef>
+        </p:style>
+        <p:txBody>
+          <a:bodyPr rtlCol="0" anchor="ctr"/>
+          <a:lstStyle/>
+          <a:p>
+            <a:pPr algn="ctr"/>
+            <a:r>
+              <a:rPr lang="fr-FR" dirty="0"/>
+              <a:t>Data Sent</a:t>
+            </a:r>
+            <a:endParaRPr lang="en-GB" dirty="0"/>
+          </a:p>
+        </p:txBody>
+      </p:sp>
+      <p:sp>
+        <p:nvSpPr>
+          <p:cNvPr id="184" name="Rectangle 183">
+            <a:extLst>
+              <a:ext uri="{FF2B5EF4-FFF2-40B4-BE49-F238E27FC236}">
+                <a16:creationId xmlns:a16="http://schemas.microsoft.com/office/drawing/2014/main" id="{70DF2D4B-F8F5-40C3-B075-1CAE3632CAFD}"/>
+              </a:ext>
+            </a:extLst>
+          </p:cNvPr>
+          <p:cNvSpPr/>
+          <p:nvPr/>
+        </p:nvSpPr>
+        <p:spPr>
+          <a:xfrm>
+            <a:off x="4065607" y="4598904"/>
+            <a:ext cx="1337733" cy="523281"/>
+          </a:xfrm>
+          <a:prstGeom prst="rect">
+            <a:avLst/>
+          </a:prstGeom>
+          <a:solidFill>
+            <a:schemeClr val="accent6">
+              <a:lumMod val="75000"/>
+            </a:schemeClr>
+          </a:solidFill>
+        </p:spPr>
+        <p:style>
+          <a:lnRef idx="2">
+            <a:schemeClr val="accent6">
+              <a:shade val="50000"/>
+            </a:schemeClr>
+          </a:lnRef>
+          <a:fillRef idx="1">
+            <a:schemeClr val="accent6"/>
+          </a:fillRef>
+          <a:effectRef idx="0">
+            <a:schemeClr val="accent6"/>
+          </a:effectRef>
+          <a:fontRef idx="minor">
+            <a:schemeClr val="lt1"/>
+          </a:fontRef>
+        </p:style>
+        <p:txBody>
+          <a:bodyPr rtlCol="0" anchor="ctr"/>
+          <a:lstStyle/>
+          <a:p>
+            <a:pPr algn="ctr"/>
+            <a:r>
+              <a:rPr lang="fr-FR" dirty="0"/>
+              <a:t>Reset </a:t>
+            </a:r>
+            <a:r>
+              <a:rPr lang="fr-FR" dirty="0" err="1"/>
+              <a:t>Recvd</a:t>
+            </a:r>
+            <a:endParaRPr lang="en-GB" dirty="0"/>
+          </a:p>
+        </p:txBody>
+      </p:sp>
+      <p:sp>
+        <p:nvSpPr>
+          <p:cNvPr id="186" name="Rectangle 185">
+            <a:extLst>
+              <a:ext uri="{FF2B5EF4-FFF2-40B4-BE49-F238E27FC236}">
+                <a16:creationId xmlns:a16="http://schemas.microsoft.com/office/drawing/2014/main" id="{48D27E21-6331-4013-A8ED-C8F531D3EB23}"/>
+              </a:ext>
+            </a:extLst>
+          </p:cNvPr>
+          <p:cNvSpPr/>
+          <p:nvPr/>
+        </p:nvSpPr>
+        <p:spPr>
+          <a:xfrm>
+            <a:off x="4065607" y="5645466"/>
+            <a:ext cx="1337733" cy="523281"/>
+          </a:xfrm>
+          <a:prstGeom prst="rect">
+            <a:avLst/>
+          </a:prstGeom>
+          <a:solidFill>
+            <a:schemeClr val="accent6">
+              <a:lumMod val="75000"/>
+            </a:schemeClr>
+          </a:solidFill>
+        </p:spPr>
+        <p:style>
+          <a:lnRef idx="2">
+            <a:schemeClr val="accent6">
+              <a:shade val="50000"/>
+            </a:schemeClr>
+          </a:lnRef>
+          <a:fillRef idx="1">
+            <a:schemeClr val="accent6"/>
+          </a:fillRef>
+          <a:effectRef idx="0">
+            <a:schemeClr val="accent6"/>
+          </a:effectRef>
+          <a:fontRef idx="minor">
+            <a:schemeClr val="lt1"/>
+          </a:fontRef>
+        </p:style>
+        <p:txBody>
+          <a:bodyPr rtlCol="0" anchor="ctr"/>
+          <a:lstStyle/>
+          <a:p>
+            <a:pPr algn="ctr"/>
+            <a:r>
+              <a:rPr lang="fr-FR" dirty="0"/>
+              <a:t>Data </a:t>
+            </a:r>
+            <a:r>
+              <a:rPr lang="fr-FR" dirty="0" err="1"/>
+              <a:t>Recvd</a:t>
+            </a:r>
+            <a:endParaRPr lang="en-GB" dirty="0"/>
+          </a:p>
+        </p:txBody>
+      </p:sp>
+      <p:cxnSp>
+        <p:nvCxnSpPr>
+          <p:cNvPr id="188" name="Connecteur droit avec flèche 187">
+            <a:extLst>
+              <a:ext uri="{FF2B5EF4-FFF2-40B4-BE49-F238E27FC236}">
+                <a16:creationId xmlns:a16="http://schemas.microsoft.com/office/drawing/2014/main" id="{08D9A169-A7C0-461D-8187-840540051B18}"/>
+              </a:ext>
+            </a:extLst>
+          </p:cNvPr>
+          <p:cNvCxnSpPr>
+            <a:stCxn id="178" idx="3"/>
+            <a:endCxn id="180" idx="1"/>
+          </p:cNvCxnSpPr>
+          <p:nvPr/>
+        </p:nvCxnSpPr>
+        <p:spPr>
+          <a:xfrm flipV="1">
+            <a:off x="1651000" y="4860545"/>
+            <a:ext cx="619671" cy="494597"/>
+          </a:xfrm>
+          <a:prstGeom prst="straightConnector1">
+            <a:avLst/>
+          </a:prstGeom>
+          <a:ln>
+            <a:solidFill>
+              <a:schemeClr val="tx1"/>
+            </a:solidFill>
+            <a:tailEnd type="triangle"/>
+          </a:ln>
+        </p:spPr>
+        <p:style>
+          <a:lnRef idx="1">
+            <a:schemeClr val="accent1"/>
+          </a:lnRef>
+          <a:fillRef idx="0">
+            <a:schemeClr val="accent1"/>
+          </a:fillRef>
+          <a:effectRef idx="0">
+            <a:schemeClr val="accent1"/>
+          </a:effectRef>
+          <a:fontRef idx="minor">
+            <a:schemeClr val="tx1"/>
+          </a:fontRef>
+        </p:style>
+      </p:cxnSp>
+      <p:cxnSp>
+        <p:nvCxnSpPr>
+          <p:cNvPr id="189" name="Connecteur droit avec flèche 188">
+            <a:extLst>
+              <a:ext uri="{FF2B5EF4-FFF2-40B4-BE49-F238E27FC236}">
+                <a16:creationId xmlns:a16="http://schemas.microsoft.com/office/drawing/2014/main" id="{2DE85B40-3301-44A8-BFE9-E72679501136}"/>
+              </a:ext>
+            </a:extLst>
+          </p:cNvPr>
+          <p:cNvCxnSpPr>
+            <a:cxnSpLocks/>
+            <a:stCxn id="178" idx="3"/>
+            <a:endCxn id="182" idx="1"/>
+          </p:cNvCxnSpPr>
+          <p:nvPr/>
+        </p:nvCxnSpPr>
+        <p:spPr>
+          <a:xfrm>
+            <a:off x="1651000" y="5355142"/>
+            <a:ext cx="619671" cy="551965"/>
+          </a:xfrm>
+          <a:prstGeom prst="straightConnector1">
+            <a:avLst/>
+          </a:prstGeom>
+          <a:ln>
+            <a:solidFill>
+              <a:schemeClr val="tx1"/>
+            </a:solidFill>
+            <a:tailEnd type="triangle"/>
+          </a:ln>
+        </p:spPr>
+        <p:style>
+          <a:lnRef idx="1">
+            <a:schemeClr val="accent1"/>
+          </a:lnRef>
+          <a:fillRef idx="0">
+            <a:schemeClr val="accent1"/>
+          </a:fillRef>
+          <a:effectRef idx="0">
+            <a:schemeClr val="accent1"/>
+          </a:effectRef>
+          <a:fontRef idx="minor">
+            <a:schemeClr val="tx1"/>
+          </a:fontRef>
+        </p:style>
+      </p:cxnSp>
+      <p:cxnSp>
+        <p:nvCxnSpPr>
+          <p:cNvPr id="192" name="Connecteur droit avec flèche 191">
+            <a:extLst>
+              <a:ext uri="{FF2B5EF4-FFF2-40B4-BE49-F238E27FC236}">
+                <a16:creationId xmlns:a16="http://schemas.microsoft.com/office/drawing/2014/main" id="{D6DA2AEB-C5AE-412C-A3CD-51F2A34EA60A}"/>
+              </a:ext>
+            </a:extLst>
+          </p:cNvPr>
+          <p:cNvCxnSpPr>
+            <a:cxnSpLocks/>
+            <a:stCxn id="182" idx="0"/>
+            <a:endCxn id="180" idx="2"/>
+          </p:cNvCxnSpPr>
+          <p:nvPr/>
+        </p:nvCxnSpPr>
+        <p:spPr>
+          <a:xfrm flipV="1">
+            <a:off x="2939538" y="5122185"/>
+            <a:ext cx="0" cy="523281"/>
+          </a:xfrm>
+          <a:prstGeom prst="straightConnector1">
+            <a:avLst/>
+          </a:prstGeom>
+          <a:ln>
+            <a:solidFill>
+              <a:schemeClr val="tx1"/>
+            </a:solidFill>
+            <a:tailEnd type="triangle"/>
+          </a:ln>
+        </p:spPr>
+        <p:style>
+          <a:lnRef idx="1">
+            <a:schemeClr val="accent1"/>
+          </a:lnRef>
+          <a:fillRef idx="0">
+            <a:schemeClr val="accent1"/>
+          </a:fillRef>
+          <a:effectRef idx="0">
+            <a:schemeClr val="accent1"/>
+          </a:effectRef>
+          <a:fontRef idx="minor">
+            <a:schemeClr val="tx1"/>
+          </a:fontRef>
+        </p:style>
+      </p:cxnSp>
+      <p:cxnSp>
+        <p:nvCxnSpPr>
+          <p:cNvPr id="195" name="Connecteur droit avec flèche 194">
+            <a:extLst>
+              <a:ext uri="{FF2B5EF4-FFF2-40B4-BE49-F238E27FC236}">
+                <a16:creationId xmlns:a16="http://schemas.microsoft.com/office/drawing/2014/main" id="{F8CF6522-BB05-404D-89B0-27210AC93648}"/>
+              </a:ext>
+            </a:extLst>
+          </p:cNvPr>
+          <p:cNvCxnSpPr>
+            <a:cxnSpLocks/>
+            <a:stCxn id="180" idx="3"/>
+            <a:endCxn id="184" idx="1"/>
+          </p:cNvCxnSpPr>
+          <p:nvPr/>
+        </p:nvCxnSpPr>
+        <p:spPr>
+          <a:xfrm>
+            <a:off x="3608404" y="4860545"/>
+            <a:ext cx="457203" cy="0"/>
+          </a:xfrm>
+          <a:prstGeom prst="straightConnector1">
+            <a:avLst/>
+          </a:prstGeom>
+          <a:ln>
+            <a:solidFill>
+              <a:schemeClr val="tx1"/>
+            </a:solidFill>
+            <a:tailEnd type="triangle"/>
+          </a:ln>
+        </p:spPr>
+        <p:style>
+          <a:lnRef idx="1">
+            <a:schemeClr val="accent1"/>
+          </a:lnRef>
+          <a:fillRef idx="0">
+            <a:schemeClr val="accent1"/>
+          </a:fillRef>
+          <a:effectRef idx="0">
+            <a:schemeClr val="accent1"/>
+          </a:effectRef>
+          <a:fontRef idx="minor">
+            <a:schemeClr val="tx1"/>
+          </a:fontRef>
+        </p:style>
+      </p:cxnSp>
+      <p:cxnSp>
+        <p:nvCxnSpPr>
+          <p:cNvPr id="215" name="Connecteur droit avec flèche 214">
+            <a:extLst>
+              <a:ext uri="{FF2B5EF4-FFF2-40B4-BE49-F238E27FC236}">
+                <a16:creationId xmlns:a16="http://schemas.microsoft.com/office/drawing/2014/main" id="{F06AB171-C4D0-4A6C-9431-6478921646FC}"/>
+              </a:ext>
+            </a:extLst>
+          </p:cNvPr>
+          <p:cNvCxnSpPr>
+            <a:cxnSpLocks/>
+          </p:cNvCxnSpPr>
+          <p:nvPr/>
+        </p:nvCxnSpPr>
+        <p:spPr>
+          <a:xfrm>
+            <a:off x="3608404" y="5907106"/>
+            <a:ext cx="457203" cy="0"/>
+          </a:xfrm>
+          <a:prstGeom prst="straightConnector1">
+            <a:avLst/>
+          </a:prstGeom>
+          <a:ln>
+            <a:solidFill>
+              <a:schemeClr val="tx1"/>
+            </a:solidFill>
+            <a:tailEnd type="triangle"/>
+          </a:ln>
+        </p:spPr>
+        <p:style>
+          <a:lnRef idx="1">
+            <a:schemeClr val="accent1"/>
+          </a:lnRef>
+          <a:fillRef idx="0">
+            <a:schemeClr val="accent1"/>
+          </a:fillRef>
+          <a:effectRef idx="0">
+            <a:schemeClr val="accent1"/>
+          </a:effectRef>
+          <a:fontRef idx="minor">
+            <a:schemeClr val="tx1"/>
+          </a:fontRef>
+        </p:style>
+      </p:cxnSp>
+      <p:sp>
+        <p:nvSpPr>
+          <p:cNvPr id="217" name="Rectangle : coins arrondis 216">
+            <a:extLst>
+              <a:ext uri="{FF2B5EF4-FFF2-40B4-BE49-F238E27FC236}">
+                <a16:creationId xmlns:a16="http://schemas.microsoft.com/office/drawing/2014/main" id="{B1EBE2B5-BCD4-4009-BC49-E3743BDA79EE}"/>
+              </a:ext>
+            </a:extLst>
+          </p:cNvPr>
+          <p:cNvSpPr/>
+          <p:nvPr/>
+        </p:nvSpPr>
+        <p:spPr>
+          <a:xfrm>
+            <a:off x="3994017" y="1578328"/>
+            <a:ext cx="1243342" cy="523220"/>
+          </a:xfrm>
+          <a:prstGeom prst="roundRect">
+            <a:avLst/>
+          </a:prstGeom>
+          <a:solidFill>
+            <a:srgbClr val="C00000"/>
+          </a:solidFill>
+        </p:spPr>
+        <p:style>
+          <a:lnRef idx="2">
+            <a:schemeClr val="accent2">
+              <a:shade val="50000"/>
+            </a:schemeClr>
+          </a:lnRef>
+          <a:fillRef idx="1">
+            <a:schemeClr val="accent2"/>
+          </a:fillRef>
+          <a:effectRef idx="0">
+            <a:schemeClr val="accent2"/>
+          </a:effectRef>
+          <a:fontRef idx="minor">
+            <a:schemeClr val="lt1"/>
+          </a:fontRef>
+        </p:style>
+        <p:txBody>
+          <a:bodyPr rtlCol="0" anchor="ctr"/>
+          <a:lstStyle/>
+          <a:p>
+            <a:pPr algn="ctr"/>
+            <a:r>
+              <a:rPr lang="fr-FR" dirty="0"/>
+              <a:t>Size </a:t>
+            </a:r>
+            <a:r>
+              <a:rPr lang="fr-FR" dirty="0" err="1"/>
+              <a:t>Known</a:t>
+            </a:r>
+            <a:endParaRPr lang="en-GB" dirty="0"/>
+          </a:p>
+        </p:txBody>
+      </p:sp>
+      <p:sp>
+        <p:nvSpPr>
+          <p:cNvPr id="219" name="Rectangle : coins arrondis 218">
+            <a:extLst>
+              <a:ext uri="{FF2B5EF4-FFF2-40B4-BE49-F238E27FC236}">
+                <a16:creationId xmlns:a16="http://schemas.microsoft.com/office/drawing/2014/main" id="{841C666D-A606-47D4-B762-686A42A8296D}"/>
+              </a:ext>
+            </a:extLst>
+          </p:cNvPr>
+          <p:cNvSpPr/>
+          <p:nvPr/>
+        </p:nvSpPr>
+        <p:spPr>
+          <a:xfrm>
+            <a:off x="5899017" y="1112444"/>
+            <a:ext cx="1243342" cy="523220"/>
+          </a:xfrm>
+          <a:prstGeom prst="roundRect">
+            <a:avLst/>
+          </a:prstGeom>
+          <a:solidFill>
+            <a:srgbClr val="C00000"/>
+          </a:solidFill>
+        </p:spPr>
+        <p:style>
+          <a:lnRef idx="2">
+            <a:schemeClr val="accent2">
+              <a:shade val="50000"/>
+            </a:schemeClr>
+          </a:lnRef>
+          <a:fillRef idx="1">
+            <a:schemeClr val="accent2"/>
+          </a:fillRef>
+          <a:effectRef idx="0">
+            <a:schemeClr val="accent2"/>
+          </a:effectRef>
+          <a:fontRef idx="minor">
+            <a:schemeClr val="lt1"/>
+          </a:fontRef>
+        </p:style>
+        <p:txBody>
+          <a:bodyPr rtlCol="0" anchor="ctr"/>
+          <a:lstStyle/>
+          <a:p>
+            <a:pPr algn="ctr"/>
+            <a:r>
+              <a:rPr lang="fr-FR" dirty="0"/>
+              <a:t>Reset </a:t>
+            </a:r>
+            <a:r>
+              <a:rPr lang="fr-FR" dirty="0" err="1"/>
+              <a:t>Recvd</a:t>
+            </a:r>
+            <a:endParaRPr lang="en-GB" dirty="0"/>
+          </a:p>
+        </p:txBody>
+      </p:sp>
+      <p:cxnSp>
+        <p:nvCxnSpPr>
+          <p:cNvPr id="220" name="Connecteur droit avec flèche 219">
+            <a:extLst>
+              <a:ext uri="{FF2B5EF4-FFF2-40B4-BE49-F238E27FC236}">
+                <a16:creationId xmlns:a16="http://schemas.microsoft.com/office/drawing/2014/main" id="{E282615C-C279-424D-AC29-946D456855CB}"/>
+              </a:ext>
+            </a:extLst>
+          </p:cNvPr>
+          <p:cNvCxnSpPr/>
+          <p:nvPr/>
+        </p:nvCxnSpPr>
+        <p:spPr>
+          <a:xfrm flipV="1">
+            <a:off x="5237359" y="1374054"/>
+            <a:ext cx="619671" cy="494597"/>
+          </a:xfrm>
+          <a:prstGeom prst="straightConnector1">
+            <a:avLst/>
+          </a:prstGeom>
+          <a:ln>
+            <a:solidFill>
+              <a:schemeClr val="tx1"/>
+            </a:solidFill>
+            <a:tailEnd type="triangle"/>
+          </a:ln>
+        </p:spPr>
+        <p:style>
+          <a:lnRef idx="1">
+            <a:schemeClr val="accent1"/>
+          </a:lnRef>
+          <a:fillRef idx="0">
+            <a:schemeClr val="accent1"/>
+          </a:fillRef>
+          <a:effectRef idx="0">
+            <a:schemeClr val="accent1"/>
+          </a:effectRef>
+          <a:fontRef idx="minor">
+            <a:schemeClr val="tx1"/>
+          </a:fontRef>
+        </p:style>
+      </p:cxnSp>
+      <p:sp>
+        <p:nvSpPr>
+          <p:cNvPr id="222" name="Rectangle : coins arrondis 221">
+            <a:extLst>
+              <a:ext uri="{FF2B5EF4-FFF2-40B4-BE49-F238E27FC236}">
+                <a16:creationId xmlns:a16="http://schemas.microsoft.com/office/drawing/2014/main" id="{3BE9F64E-183E-4FC2-9E85-9AEC4A332740}"/>
+              </a:ext>
+            </a:extLst>
+          </p:cNvPr>
+          <p:cNvSpPr/>
+          <p:nvPr/>
+        </p:nvSpPr>
+        <p:spPr>
+          <a:xfrm>
+            <a:off x="5899017" y="2133948"/>
+            <a:ext cx="1243342" cy="523220"/>
+          </a:xfrm>
+          <a:prstGeom prst="roundRect">
+            <a:avLst/>
+          </a:prstGeom>
+          <a:solidFill>
+            <a:srgbClr val="C00000"/>
+          </a:solidFill>
+        </p:spPr>
+        <p:style>
+          <a:lnRef idx="2">
+            <a:schemeClr val="accent2">
+              <a:shade val="50000"/>
+            </a:schemeClr>
+          </a:lnRef>
+          <a:fillRef idx="1">
+            <a:schemeClr val="accent2"/>
+          </a:fillRef>
+          <a:effectRef idx="0">
+            <a:schemeClr val="accent2"/>
+          </a:effectRef>
+          <a:fontRef idx="minor">
+            <a:schemeClr val="lt1"/>
+          </a:fontRef>
+        </p:style>
+        <p:txBody>
+          <a:bodyPr rtlCol="0" anchor="ctr"/>
+          <a:lstStyle/>
+          <a:p>
+            <a:pPr algn="ctr"/>
+            <a:r>
+              <a:rPr lang="fr-FR" dirty="0"/>
+              <a:t>Data </a:t>
+            </a:r>
+            <a:r>
+              <a:rPr lang="fr-FR" dirty="0" err="1"/>
+              <a:t>Recvd</a:t>
+            </a:r>
+            <a:endParaRPr lang="en-GB" dirty="0"/>
+          </a:p>
+        </p:txBody>
+      </p:sp>
+      <p:cxnSp>
+        <p:nvCxnSpPr>
+          <p:cNvPr id="223" name="Connecteur droit avec flèche 222">
+            <a:extLst>
+              <a:ext uri="{FF2B5EF4-FFF2-40B4-BE49-F238E27FC236}">
+                <a16:creationId xmlns:a16="http://schemas.microsoft.com/office/drawing/2014/main" id="{DF236E6B-21F7-4A46-966C-032D44C15BEF}"/>
+              </a:ext>
+            </a:extLst>
+          </p:cNvPr>
+          <p:cNvCxnSpPr>
+            <a:cxnSpLocks/>
+          </p:cNvCxnSpPr>
+          <p:nvPr/>
+        </p:nvCxnSpPr>
+        <p:spPr>
+          <a:xfrm>
+            <a:off x="5258352" y="1868651"/>
+            <a:ext cx="619671" cy="551965"/>
+          </a:xfrm>
+          <a:prstGeom prst="straightConnector1">
+            <a:avLst/>
+          </a:prstGeom>
+          <a:ln>
+            <a:solidFill>
+              <a:schemeClr val="tx1"/>
+            </a:solidFill>
+            <a:tailEnd type="triangle"/>
+          </a:ln>
+        </p:spPr>
+        <p:style>
+          <a:lnRef idx="1">
+            <a:schemeClr val="accent1"/>
+          </a:lnRef>
+          <a:fillRef idx="0">
+            <a:schemeClr val="accent1"/>
+          </a:fillRef>
+          <a:effectRef idx="0">
+            <a:schemeClr val="accent1"/>
+          </a:effectRef>
+          <a:fontRef idx="minor">
+            <a:schemeClr val="tx1"/>
+          </a:fontRef>
+        </p:style>
+      </p:cxnSp>
+      <p:cxnSp>
+        <p:nvCxnSpPr>
+          <p:cNvPr id="224" name="Connecteur droit avec flèche 223">
+            <a:extLst>
+              <a:ext uri="{FF2B5EF4-FFF2-40B4-BE49-F238E27FC236}">
+                <a16:creationId xmlns:a16="http://schemas.microsoft.com/office/drawing/2014/main" id="{710F0520-3080-405A-8A08-0596A1BCD120}"/>
+              </a:ext>
+            </a:extLst>
+          </p:cNvPr>
+          <p:cNvCxnSpPr>
+            <a:cxnSpLocks/>
+          </p:cNvCxnSpPr>
+          <p:nvPr/>
+        </p:nvCxnSpPr>
+        <p:spPr>
+          <a:xfrm flipV="1">
+            <a:off x="6305416" y="1607010"/>
+            <a:ext cx="0" cy="523281"/>
+          </a:xfrm>
+          <a:prstGeom prst="straightConnector1">
+            <a:avLst/>
+          </a:prstGeom>
+          <a:ln>
+            <a:solidFill>
+              <a:schemeClr val="tx1"/>
+            </a:solidFill>
+            <a:tailEnd type="triangle"/>
+          </a:ln>
+        </p:spPr>
+        <p:style>
+          <a:lnRef idx="1">
+            <a:schemeClr val="accent1"/>
+          </a:lnRef>
+          <a:fillRef idx="0">
+            <a:schemeClr val="accent1"/>
+          </a:fillRef>
+          <a:effectRef idx="0">
+            <a:schemeClr val="accent1"/>
+          </a:effectRef>
+          <a:fontRef idx="minor">
+            <a:schemeClr val="tx1"/>
+          </a:fontRef>
+        </p:style>
+      </p:cxnSp>
+      <p:cxnSp>
+        <p:nvCxnSpPr>
+          <p:cNvPr id="225" name="Connecteur droit avec flèche 224">
+            <a:extLst>
+              <a:ext uri="{FF2B5EF4-FFF2-40B4-BE49-F238E27FC236}">
+                <a16:creationId xmlns:a16="http://schemas.microsoft.com/office/drawing/2014/main" id="{FD2AD9F1-AAA5-40ED-9EF5-A8FD862862E1}"/>
+              </a:ext>
+            </a:extLst>
+          </p:cNvPr>
+          <p:cNvCxnSpPr>
+            <a:cxnSpLocks/>
+          </p:cNvCxnSpPr>
+          <p:nvPr/>
+        </p:nvCxnSpPr>
+        <p:spPr>
+          <a:xfrm>
+            <a:off x="6753803" y="1635664"/>
+            <a:ext cx="0" cy="508969"/>
+          </a:xfrm>
+          <a:prstGeom prst="straightConnector1">
+            <a:avLst/>
+          </a:prstGeom>
+          <a:ln>
+            <a:solidFill>
+              <a:schemeClr val="tx1"/>
+            </a:solidFill>
+            <a:tailEnd type="triangle"/>
+          </a:ln>
+        </p:spPr>
+        <p:style>
+          <a:lnRef idx="1">
+            <a:schemeClr val="accent1"/>
+          </a:lnRef>
+          <a:fillRef idx="0">
+            <a:schemeClr val="accent1"/>
+          </a:fillRef>
+          <a:effectRef idx="0">
+            <a:schemeClr val="accent1"/>
+          </a:effectRef>
+          <a:fontRef idx="minor">
+            <a:schemeClr val="tx1"/>
+          </a:fontRef>
+        </p:style>
+      </p:cxnSp>
+      <p:sp>
+        <p:nvSpPr>
+          <p:cNvPr id="230" name="Rectangle : coins arrondis 229">
+            <a:extLst>
+              <a:ext uri="{FF2B5EF4-FFF2-40B4-BE49-F238E27FC236}">
+                <a16:creationId xmlns:a16="http://schemas.microsoft.com/office/drawing/2014/main" id="{13F37134-309F-4816-9A78-651A5D7CB676}"/>
+              </a:ext>
+            </a:extLst>
+          </p:cNvPr>
+          <p:cNvSpPr/>
+          <p:nvPr/>
+        </p:nvSpPr>
+        <p:spPr>
+          <a:xfrm>
+            <a:off x="7590745" y="1098132"/>
+            <a:ext cx="1243342" cy="523220"/>
+          </a:xfrm>
+          <a:prstGeom prst="roundRect">
+            <a:avLst/>
+          </a:prstGeom>
+          <a:solidFill>
+            <a:schemeClr val="accent6">
+              <a:lumMod val="75000"/>
+            </a:schemeClr>
+          </a:solidFill>
+        </p:spPr>
+        <p:style>
+          <a:lnRef idx="2">
+            <a:schemeClr val="accent2">
+              <a:shade val="50000"/>
+            </a:schemeClr>
+          </a:lnRef>
+          <a:fillRef idx="1">
+            <a:schemeClr val="accent2"/>
+          </a:fillRef>
+          <a:effectRef idx="0">
+            <a:schemeClr val="accent2"/>
+          </a:effectRef>
+          <a:fontRef idx="minor">
+            <a:schemeClr val="lt1"/>
+          </a:fontRef>
+        </p:style>
+        <p:txBody>
+          <a:bodyPr rtlCol="0" anchor="ctr"/>
+          <a:lstStyle/>
+          <a:p>
+            <a:pPr algn="ctr"/>
+            <a:r>
+              <a:rPr lang="fr-FR" dirty="0"/>
+              <a:t>Reset Read</a:t>
+            </a:r>
+            <a:endParaRPr lang="en-GB" dirty="0"/>
+          </a:p>
+        </p:txBody>
+      </p:sp>
+      <p:sp>
+        <p:nvSpPr>
+          <p:cNvPr id="232" name="Rectangle : coins arrondis 231">
+            <a:extLst>
+              <a:ext uri="{FF2B5EF4-FFF2-40B4-BE49-F238E27FC236}">
+                <a16:creationId xmlns:a16="http://schemas.microsoft.com/office/drawing/2014/main" id="{E561FA01-2DAB-42B4-95C2-0E356AA4D4DF}"/>
+              </a:ext>
+            </a:extLst>
+          </p:cNvPr>
+          <p:cNvSpPr/>
+          <p:nvPr/>
+        </p:nvSpPr>
+        <p:spPr>
+          <a:xfrm>
+            <a:off x="7629584" y="2144633"/>
+            <a:ext cx="1243342" cy="523220"/>
+          </a:xfrm>
+          <a:prstGeom prst="roundRect">
+            <a:avLst/>
+          </a:prstGeom>
+          <a:solidFill>
+            <a:schemeClr val="accent6">
+              <a:lumMod val="75000"/>
+            </a:schemeClr>
+          </a:solidFill>
+        </p:spPr>
+        <p:style>
+          <a:lnRef idx="2">
+            <a:schemeClr val="accent2">
+              <a:shade val="50000"/>
+            </a:schemeClr>
+          </a:lnRef>
+          <a:fillRef idx="1">
+            <a:schemeClr val="accent2"/>
+          </a:fillRef>
+          <a:effectRef idx="0">
+            <a:schemeClr val="accent2"/>
+          </a:effectRef>
+          <a:fontRef idx="minor">
+            <a:schemeClr val="lt1"/>
+          </a:fontRef>
+        </p:style>
+        <p:txBody>
+          <a:bodyPr rtlCol="0" anchor="ctr"/>
+          <a:lstStyle/>
+          <a:p>
+            <a:pPr algn="ctr"/>
+            <a:r>
+              <a:rPr lang="fr-FR" dirty="0"/>
+              <a:t>Data Read</a:t>
+            </a:r>
+            <a:endParaRPr lang="en-GB" dirty="0"/>
+          </a:p>
+        </p:txBody>
+      </p:sp>
+      <p:cxnSp>
+        <p:nvCxnSpPr>
+          <p:cNvPr id="233" name="Connecteur droit avec flèche 232">
+            <a:extLst>
+              <a:ext uri="{FF2B5EF4-FFF2-40B4-BE49-F238E27FC236}">
+                <a16:creationId xmlns:a16="http://schemas.microsoft.com/office/drawing/2014/main" id="{AB81251E-8436-4FCE-A331-264E6593C451}"/>
+              </a:ext>
+            </a:extLst>
+          </p:cNvPr>
+          <p:cNvCxnSpPr>
+            <a:cxnSpLocks/>
+          </p:cNvCxnSpPr>
+          <p:nvPr/>
+        </p:nvCxnSpPr>
+        <p:spPr>
+          <a:xfrm>
+            <a:off x="7142359" y="1374054"/>
+            <a:ext cx="457203" cy="0"/>
+          </a:xfrm>
+          <a:prstGeom prst="straightConnector1">
+            <a:avLst/>
+          </a:prstGeom>
+          <a:ln>
+            <a:solidFill>
+              <a:schemeClr val="tx1"/>
+            </a:solidFill>
+            <a:tailEnd type="triangle"/>
+          </a:ln>
+        </p:spPr>
+        <p:style>
+          <a:lnRef idx="1">
+            <a:schemeClr val="accent1"/>
+          </a:lnRef>
+          <a:fillRef idx="0">
+            <a:schemeClr val="accent1"/>
+          </a:fillRef>
+          <a:effectRef idx="0">
+            <a:schemeClr val="accent1"/>
+          </a:effectRef>
+          <a:fontRef idx="minor">
+            <a:schemeClr val="tx1"/>
+          </a:fontRef>
+        </p:style>
+      </p:cxnSp>
+      <p:cxnSp>
+        <p:nvCxnSpPr>
+          <p:cNvPr id="234" name="Connecteur droit avec flèche 233">
+            <a:extLst>
+              <a:ext uri="{FF2B5EF4-FFF2-40B4-BE49-F238E27FC236}">
+                <a16:creationId xmlns:a16="http://schemas.microsoft.com/office/drawing/2014/main" id="{FE902090-C3A8-4B74-BEF8-4402648111E1}"/>
+              </a:ext>
+            </a:extLst>
+          </p:cNvPr>
+          <p:cNvCxnSpPr>
+            <a:cxnSpLocks/>
+          </p:cNvCxnSpPr>
+          <p:nvPr/>
+        </p:nvCxnSpPr>
+        <p:spPr>
+          <a:xfrm>
+            <a:off x="7158036" y="2420616"/>
+            <a:ext cx="457203" cy="0"/>
+          </a:xfrm>
+          <a:prstGeom prst="straightConnector1">
+            <a:avLst/>
+          </a:prstGeom>
+          <a:ln>
+            <a:solidFill>
+              <a:schemeClr val="tx1"/>
+            </a:solidFill>
+            <a:tailEnd type="triangle"/>
+          </a:ln>
+        </p:spPr>
+        <p:style>
+          <a:lnRef idx="1">
+            <a:schemeClr val="accent1"/>
+          </a:lnRef>
+          <a:fillRef idx="0">
+            <a:schemeClr val="accent1"/>
+          </a:fillRef>
+          <a:effectRef idx="0">
+            <a:schemeClr val="accent1"/>
+          </a:effectRef>
+          <a:fontRef idx="minor">
+            <a:schemeClr val="tx1"/>
+          </a:fontRef>
+        </p:style>
+      </p:cxnSp>
+      <p:cxnSp>
+        <p:nvCxnSpPr>
+          <p:cNvPr id="235" name="Connecteur droit avec flèche 234">
+            <a:extLst>
+              <a:ext uri="{FF2B5EF4-FFF2-40B4-BE49-F238E27FC236}">
+                <a16:creationId xmlns:a16="http://schemas.microsoft.com/office/drawing/2014/main" id="{9A07EC96-3AC2-48A7-B279-3B7E74DA5465}"/>
+              </a:ext>
+            </a:extLst>
+          </p:cNvPr>
+          <p:cNvCxnSpPr>
+            <a:cxnSpLocks/>
+            <a:stCxn id="164" idx="5"/>
+            <a:endCxn id="176" idx="0"/>
+          </p:cNvCxnSpPr>
+          <p:nvPr/>
+        </p:nvCxnSpPr>
+        <p:spPr>
+          <a:xfrm>
+            <a:off x="2507788" y="950893"/>
+            <a:ext cx="332150" cy="606439"/>
+          </a:xfrm>
+          <a:prstGeom prst="straightConnector1">
+            <a:avLst/>
+          </a:prstGeom>
+          <a:ln>
+            <a:solidFill>
+              <a:schemeClr val="tx1"/>
+            </a:solidFill>
+            <a:tailEnd type="triangle"/>
+          </a:ln>
+        </p:spPr>
+        <p:style>
+          <a:lnRef idx="1">
+            <a:schemeClr val="accent1"/>
+          </a:lnRef>
+          <a:fillRef idx="0">
+            <a:schemeClr val="accent1"/>
+          </a:fillRef>
+          <a:effectRef idx="0">
+            <a:schemeClr val="accent1"/>
+          </a:effectRef>
+          <a:fontRef idx="minor">
+            <a:schemeClr val="tx1"/>
+          </a:fontRef>
+        </p:style>
+      </p:cxnSp>
+      <p:cxnSp>
+        <p:nvCxnSpPr>
+          <p:cNvPr id="239" name="Connecteur droit avec flèche 238">
+            <a:extLst>
+              <a:ext uri="{FF2B5EF4-FFF2-40B4-BE49-F238E27FC236}">
+                <a16:creationId xmlns:a16="http://schemas.microsoft.com/office/drawing/2014/main" id="{2E747C15-F807-45E7-BFDC-B8E819925F1A}"/>
+              </a:ext>
+            </a:extLst>
+          </p:cNvPr>
+          <p:cNvCxnSpPr>
+            <a:cxnSpLocks/>
+            <a:stCxn id="164" idx="3"/>
+            <a:endCxn id="175" idx="0"/>
+          </p:cNvCxnSpPr>
+          <p:nvPr/>
+        </p:nvCxnSpPr>
+        <p:spPr>
+          <a:xfrm flipH="1">
+            <a:off x="982134" y="950893"/>
+            <a:ext cx="371575" cy="622917"/>
+          </a:xfrm>
+          <a:prstGeom prst="straightConnector1">
+            <a:avLst/>
+          </a:prstGeom>
+          <a:ln>
+            <a:solidFill>
+              <a:schemeClr val="tx1"/>
+            </a:solidFill>
+            <a:tailEnd type="triangle"/>
+          </a:ln>
+        </p:spPr>
+        <p:style>
+          <a:lnRef idx="1">
+            <a:schemeClr val="accent1"/>
+          </a:lnRef>
+          <a:fillRef idx="0">
+            <a:schemeClr val="accent1"/>
+          </a:fillRef>
+          <a:effectRef idx="0">
+            <a:schemeClr val="accent1"/>
+          </a:effectRef>
+          <a:fontRef idx="minor">
+            <a:schemeClr val="tx1"/>
+          </a:fontRef>
+        </p:style>
+      </p:cxnSp>
+      <p:cxnSp>
+        <p:nvCxnSpPr>
+          <p:cNvPr id="242" name="Connecteur droit avec flèche 241">
+            <a:extLst>
+              <a:ext uri="{FF2B5EF4-FFF2-40B4-BE49-F238E27FC236}">
+                <a16:creationId xmlns:a16="http://schemas.microsoft.com/office/drawing/2014/main" id="{54CC4135-177E-4569-9CFA-193A1B456190}"/>
+              </a:ext>
+            </a:extLst>
+          </p:cNvPr>
+          <p:cNvCxnSpPr>
+            <a:cxnSpLocks/>
+            <a:stCxn id="175" idx="2"/>
+            <a:endCxn id="178" idx="0"/>
+          </p:cNvCxnSpPr>
+          <p:nvPr/>
+        </p:nvCxnSpPr>
+        <p:spPr>
+          <a:xfrm>
+            <a:off x="982134" y="2097091"/>
+            <a:ext cx="0" cy="2996410"/>
+          </a:xfrm>
+          <a:prstGeom prst="straightConnector1">
+            <a:avLst/>
+          </a:prstGeom>
+          <a:ln>
+            <a:solidFill>
+              <a:schemeClr val="tx1"/>
+            </a:solidFill>
+            <a:tailEnd type="triangle"/>
+          </a:ln>
+        </p:spPr>
+        <p:style>
+          <a:lnRef idx="1">
+            <a:schemeClr val="accent1"/>
+          </a:lnRef>
+          <a:fillRef idx="0">
+            <a:schemeClr val="accent1"/>
+          </a:fillRef>
+          <a:effectRef idx="0">
+            <a:schemeClr val="accent1"/>
+          </a:effectRef>
+          <a:fontRef idx="minor">
+            <a:schemeClr val="tx1"/>
+          </a:fontRef>
+        </p:style>
+      </p:cxnSp>
+      <p:cxnSp>
+        <p:nvCxnSpPr>
+          <p:cNvPr id="246" name="Connecteur droit avec flèche 245">
+            <a:extLst>
+              <a:ext uri="{FF2B5EF4-FFF2-40B4-BE49-F238E27FC236}">
+                <a16:creationId xmlns:a16="http://schemas.microsoft.com/office/drawing/2014/main" id="{02386CF8-1EE3-4FE8-AA13-AD36A0F7108E}"/>
+              </a:ext>
+            </a:extLst>
+          </p:cNvPr>
+          <p:cNvCxnSpPr>
+            <a:cxnSpLocks/>
+            <a:stCxn id="176" idx="3"/>
+            <a:endCxn id="217" idx="1"/>
+          </p:cNvCxnSpPr>
+          <p:nvPr/>
+        </p:nvCxnSpPr>
+        <p:spPr>
+          <a:xfrm>
+            <a:off x="3461609" y="1818942"/>
+            <a:ext cx="532408" cy="20996"/>
+          </a:xfrm>
+          <a:prstGeom prst="straightConnector1">
+            <a:avLst/>
+          </a:prstGeom>
+          <a:ln>
+            <a:solidFill>
+              <a:schemeClr val="tx1"/>
+            </a:solidFill>
+            <a:tailEnd type="triangle"/>
+          </a:ln>
+        </p:spPr>
+        <p:style>
+          <a:lnRef idx="1">
+            <a:schemeClr val="accent1"/>
+          </a:lnRef>
+          <a:fillRef idx="0">
+            <a:schemeClr val="accent1"/>
+          </a:fillRef>
+          <a:effectRef idx="0">
+            <a:schemeClr val="accent1"/>
+          </a:effectRef>
+          <a:fontRef idx="minor">
+            <a:schemeClr val="tx1"/>
+          </a:fontRef>
+        </p:style>
+      </p:cxnSp>
+      <p:cxnSp>
+        <p:nvCxnSpPr>
+          <p:cNvPr id="251" name="Connecteur droit avec flèche 250">
+            <a:extLst>
+              <a:ext uri="{FF2B5EF4-FFF2-40B4-BE49-F238E27FC236}">
+                <a16:creationId xmlns:a16="http://schemas.microsoft.com/office/drawing/2014/main" id="{B45C2B87-9299-4486-B04F-AA6E045EEA78}"/>
+              </a:ext>
+            </a:extLst>
+          </p:cNvPr>
+          <p:cNvCxnSpPr>
+            <a:stCxn id="168" idx="7"/>
+            <a:endCxn id="217" idx="2"/>
+          </p:cNvCxnSpPr>
+          <p:nvPr/>
+        </p:nvCxnSpPr>
+        <p:spPr>
+          <a:xfrm flipV="1">
+            <a:off x="2507788" y="2101548"/>
+            <a:ext cx="2107900" cy="921281"/>
+          </a:xfrm>
+          <a:prstGeom prst="straightConnector1">
+            <a:avLst/>
+          </a:prstGeom>
+          <a:ln>
+            <a:headEnd type="triangle"/>
+            <a:tailEnd type="triangle"/>
+          </a:ln>
+        </p:spPr>
+        <p:style>
+          <a:lnRef idx="1">
+            <a:schemeClr val="accent1"/>
+          </a:lnRef>
+          <a:fillRef idx="0">
+            <a:schemeClr val="accent1"/>
+          </a:fillRef>
+          <a:effectRef idx="0">
+            <a:schemeClr val="accent1"/>
+          </a:effectRef>
+          <a:fontRef idx="minor">
+            <a:schemeClr val="tx1"/>
+          </a:fontRef>
+        </p:style>
+      </p:cxnSp>
+      <p:cxnSp>
+        <p:nvCxnSpPr>
+          <p:cNvPr id="252" name="Connecteur droit avec flèche 251">
+            <a:extLst>
+              <a:ext uri="{FF2B5EF4-FFF2-40B4-BE49-F238E27FC236}">
+                <a16:creationId xmlns:a16="http://schemas.microsoft.com/office/drawing/2014/main" id="{439C077F-27BB-4F3B-B59E-6A55E27B6D38}"/>
+              </a:ext>
+            </a:extLst>
+          </p:cNvPr>
+          <p:cNvCxnSpPr>
+            <a:cxnSpLocks/>
+            <a:endCxn id="168" idx="4"/>
+          </p:cNvCxnSpPr>
+          <p:nvPr/>
+        </p:nvCxnSpPr>
+        <p:spPr>
+          <a:xfrm flipH="1" flipV="1">
+            <a:off x="1930749" y="3644609"/>
+            <a:ext cx="385835" cy="2000857"/>
+          </a:xfrm>
+          <a:prstGeom prst="straightConnector1">
+            <a:avLst/>
+          </a:prstGeom>
+          <a:ln>
+            <a:headEnd type="triangle"/>
+            <a:tailEnd type="triangle"/>
+          </a:ln>
+        </p:spPr>
+        <p:style>
+          <a:lnRef idx="1">
+            <a:schemeClr val="accent1"/>
+          </a:lnRef>
+          <a:fillRef idx="0">
+            <a:schemeClr val="accent1"/>
+          </a:fillRef>
+          <a:effectRef idx="0">
+            <a:schemeClr val="accent1"/>
+          </a:effectRef>
+          <a:fontRef idx="minor">
+            <a:schemeClr val="tx1"/>
+          </a:fontRef>
+        </p:style>
+      </p:cxnSp>
+      <p:cxnSp>
+        <p:nvCxnSpPr>
+          <p:cNvPr id="256" name="Connecteur droit avec flèche 255">
+            <a:extLst>
+              <a:ext uri="{FF2B5EF4-FFF2-40B4-BE49-F238E27FC236}">
+                <a16:creationId xmlns:a16="http://schemas.microsoft.com/office/drawing/2014/main" id="{AAF2B872-E6D7-42D7-869A-0AF764772FD8}"/>
+              </a:ext>
+            </a:extLst>
+          </p:cNvPr>
+          <p:cNvCxnSpPr>
+            <a:cxnSpLocks/>
+            <a:stCxn id="182" idx="3"/>
+            <a:endCxn id="170" idx="2"/>
+          </p:cNvCxnSpPr>
+          <p:nvPr/>
+        </p:nvCxnSpPr>
+        <p:spPr>
+          <a:xfrm flipV="1">
+            <a:off x="3608404" y="4598904"/>
+            <a:ext cx="3813872" cy="1308203"/>
+          </a:xfrm>
+          <a:prstGeom prst="straightConnector1">
+            <a:avLst/>
+          </a:prstGeom>
+          <a:ln>
+            <a:headEnd type="triangle"/>
+            <a:tailEnd type="triangle"/>
+          </a:ln>
+        </p:spPr>
+        <p:style>
+          <a:lnRef idx="1">
+            <a:schemeClr val="accent1"/>
+          </a:lnRef>
+          <a:fillRef idx="0">
+            <a:schemeClr val="accent1"/>
+          </a:fillRef>
+          <a:effectRef idx="0">
+            <a:schemeClr val="accent1"/>
+          </a:effectRef>
+          <a:fontRef idx="minor">
+            <a:schemeClr val="tx1"/>
+          </a:fontRef>
+        </p:style>
+      </p:cxnSp>
+      <p:cxnSp>
+        <p:nvCxnSpPr>
+          <p:cNvPr id="259" name="Connecteur droit avec flèche 258">
+            <a:extLst>
+              <a:ext uri="{FF2B5EF4-FFF2-40B4-BE49-F238E27FC236}">
+                <a16:creationId xmlns:a16="http://schemas.microsoft.com/office/drawing/2014/main" id="{15F80B20-804A-4682-9538-EC1F3419BD2A}"/>
+              </a:ext>
+            </a:extLst>
+          </p:cNvPr>
+          <p:cNvCxnSpPr>
+            <a:cxnSpLocks/>
+            <a:stCxn id="232" idx="2"/>
+            <a:endCxn id="170" idx="0"/>
+          </p:cNvCxnSpPr>
+          <p:nvPr/>
+        </p:nvCxnSpPr>
+        <p:spPr>
+          <a:xfrm flipH="1">
+            <a:off x="8238333" y="2667853"/>
+            <a:ext cx="12922" cy="1566821"/>
+          </a:xfrm>
+          <a:prstGeom prst="straightConnector1">
+            <a:avLst/>
+          </a:prstGeom>
+          <a:ln>
+            <a:headEnd type="triangle"/>
+            <a:tailEnd type="triangle"/>
+          </a:ln>
+        </p:spPr>
+        <p:style>
+          <a:lnRef idx="1">
+            <a:schemeClr val="accent1"/>
+          </a:lnRef>
+          <a:fillRef idx="0">
+            <a:schemeClr val="accent1"/>
+          </a:fillRef>
+          <a:effectRef idx="0">
+            <a:schemeClr val="accent1"/>
+          </a:effectRef>
+          <a:fontRef idx="minor">
+            <a:schemeClr val="tx1"/>
+          </a:fontRef>
+        </p:style>
+      </p:cxnSp>
+      <p:cxnSp>
+        <p:nvCxnSpPr>
+          <p:cNvPr id="265" name="Connecteur droit avec flèche 264">
+            <a:extLst>
+              <a:ext uri="{FF2B5EF4-FFF2-40B4-BE49-F238E27FC236}">
+                <a16:creationId xmlns:a16="http://schemas.microsoft.com/office/drawing/2014/main" id="{3E54D7A2-DE93-4811-861F-F48F159567E4}"/>
+              </a:ext>
+            </a:extLst>
+          </p:cNvPr>
+          <p:cNvCxnSpPr>
+            <a:cxnSpLocks/>
+          </p:cNvCxnSpPr>
+          <p:nvPr/>
+        </p:nvCxnSpPr>
+        <p:spPr>
+          <a:xfrm>
+            <a:off x="8460187" y="1635664"/>
+            <a:ext cx="0" cy="2599010"/>
+          </a:xfrm>
+          <a:prstGeom prst="straightConnector1">
+            <a:avLst/>
+          </a:prstGeom>
+          <a:ln>
+            <a:headEnd type="triangle"/>
+            <a:tailEnd type="triangle"/>
+          </a:ln>
+        </p:spPr>
+        <p:style>
+          <a:lnRef idx="1">
+            <a:schemeClr val="accent1"/>
+          </a:lnRef>
+          <a:fillRef idx="0">
+            <a:schemeClr val="accent1"/>
+          </a:fillRef>
+          <a:effectRef idx="0">
+            <a:schemeClr val="accent1"/>
+          </a:effectRef>
+          <a:fontRef idx="minor">
+            <a:schemeClr val="tx1"/>
+          </a:fontRef>
+        </p:style>
+      </p:cxnSp>
+      <p:cxnSp>
+        <p:nvCxnSpPr>
+          <p:cNvPr id="267" name="Connecteur droit avec flèche 266">
+            <a:extLst>
+              <a:ext uri="{FF2B5EF4-FFF2-40B4-BE49-F238E27FC236}">
+                <a16:creationId xmlns:a16="http://schemas.microsoft.com/office/drawing/2014/main" id="{F7AC6A69-12E7-4B67-A60E-BB2E6236BA96}"/>
+              </a:ext>
+            </a:extLst>
+          </p:cNvPr>
+          <p:cNvCxnSpPr>
+            <a:cxnSpLocks/>
+            <a:stCxn id="172" idx="1"/>
+          </p:cNvCxnSpPr>
+          <p:nvPr/>
+        </p:nvCxnSpPr>
+        <p:spPr>
+          <a:xfrm flipH="1" flipV="1">
+            <a:off x="4896669" y="2130291"/>
+            <a:ext cx="622291" cy="1419909"/>
+          </a:xfrm>
+          <a:prstGeom prst="straightConnector1">
+            <a:avLst/>
+          </a:prstGeom>
+          <a:ln>
+            <a:headEnd type="triangle"/>
+            <a:tailEnd type="triangle"/>
+          </a:ln>
+        </p:spPr>
+        <p:style>
+          <a:lnRef idx="1">
+            <a:schemeClr val="accent1"/>
+          </a:lnRef>
+          <a:fillRef idx="0">
+            <a:schemeClr val="accent1"/>
+          </a:fillRef>
+          <a:effectRef idx="0">
+            <a:schemeClr val="accent1"/>
+          </a:effectRef>
+          <a:fontRef idx="minor">
+            <a:schemeClr val="tx1"/>
+          </a:fontRef>
+        </p:style>
+      </p:cxnSp>
+      <p:cxnSp>
+        <p:nvCxnSpPr>
+          <p:cNvPr id="270" name="Connecteur droit avec flèche 269">
+            <a:extLst>
+              <a:ext uri="{FF2B5EF4-FFF2-40B4-BE49-F238E27FC236}">
+                <a16:creationId xmlns:a16="http://schemas.microsoft.com/office/drawing/2014/main" id="{99F3C843-32BA-445B-A4F8-EBD52E25820E}"/>
+              </a:ext>
+            </a:extLst>
+          </p:cNvPr>
+          <p:cNvCxnSpPr>
+            <a:cxnSpLocks/>
+            <a:endCxn id="172" idx="4"/>
+          </p:cNvCxnSpPr>
+          <p:nvPr/>
+        </p:nvCxnSpPr>
+        <p:spPr>
+          <a:xfrm flipV="1">
+            <a:off x="5255059" y="4171980"/>
+            <a:ext cx="840941" cy="1444802"/>
+          </a:xfrm>
+          <a:prstGeom prst="straightConnector1">
+            <a:avLst/>
+          </a:prstGeom>
+          <a:ln>
+            <a:headEnd type="triangle"/>
+            <a:tailEnd type="triangle"/>
+          </a:ln>
+        </p:spPr>
+        <p:style>
+          <a:lnRef idx="1">
+            <a:schemeClr val="accent1"/>
+          </a:lnRef>
+          <a:fillRef idx="0">
+            <a:schemeClr val="accent1"/>
+          </a:fillRef>
+          <a:effectRef idx="0">
+            <a:schemeClr val="accent1"/>
+          </a:effectRef>
+          <a:fontRef idx="minor">
+            <a:schemeClr val="tx1"/>
+          </a:fontRef>
+        </p:style>
+      </p:cxnSp>
+      <p:cxnSp>
+        <p:nvCxnSpPr>
+          <p:cNvPr id="273" name="Connecteur droit avec flèche 272">
+            <a:extLst>
+              <a:ext uri="{FF2B5EF4-FFF2-40B4-BE49-F238E27FC236}">
+                <a16:creationId xmlns:a16="http://schemas.microsoft.com/office/drawing/2014/main" id="{99E80C1D-CD0F-43B7-9F88-8A2CA1CFF469}"/>
+              </a:ext>
+            </a:extLst>
+          </p:cNvPr>
+          <p:cNvCxnSpPr>
+            <a:cxnSpLocks/>
+            <a:endCxn id="172" idx="3"/>
+          </p:cNvCxnSpPr>
+          <p:nvPr/>
+        </p:nvCxnSpPr>
+        <p:spPr>
+          <a:xfrm flipV="1">
+            <a:off x="5207814" y="4065300"/>
+            <a:ext cx="311146" cy="501694"/>
+          </a:xfrm>
+          <a:prstGeom prst="straightConnector1">
+            <a:avLst/>
+          </a:prstGeom>
+          <a:ln>
+            <a:headEnd type="triangle"/>
+            <a:tailEnd type="triangle"/>
+          </a:ln>
+        </p:spPr>
+        <p:style>
+          <a:lnRef idx="1">
+            <a:schemeClr val="accent1"/>
+          </a:lnRef>
+          <a:fillRef idx="0">
+            <a:schemeClr val="accent1"/>
+          </a:fillRef>
+          <a:effectRef idx="0">
+            <a:schemeClr val="accent1"/>
+          </a:effectRef>
+          <a:fontRef idx="minor">
+            <a:schemeClr val="tx1"/>
+          </a:fontRef>
+        </p:style>
+      </p:cxnSp>
+      <p:cxnSp>
+        <p:nvCxnSpPr>
+          <p:cNvPr id="276" name="Connecteur droit avec flèche 275">
+            <a:extLst>
+              <a:ext uri="{FF2B5EF4-FFF2-40B4-BE49-F238E27FC236}">
+                <a16:creationId xmlns:a16="http://schemas.microsoft.com/office/drawing/2014/main" id="{39D10607-7465-4ED6-AD0B-FEF292123988}"/>
+              </a:ext>
+            </a:extLst>
+          </p:cNvPr>
+          <p:cNvCxnSpPr>
+            <a:cxnSpLocks/>
+            <a:stCxn id="174" idx="2"/>
+            <a:endCxn id="184" idx="3"/>
+          </p:cNvCxnSpPr>
+          <p:nvPr/>
+        </p:nvCxnSpPr>
+        <p:spPr>
+          <a:xfrm flipH="1">
+            <a:off x="5403340" y="3444301"/>
+            <a:ext cx="4197860" cy="1416244"/>
+          </a:xfrm>
+          <a:prstGeom prst="straightConnector1">
+            <a:avLst/>
+          </a:prstGeom>
+          <a:ln>
+            <a:headEnd type="triangle"/>
+            <a:tailEnd type="triangle"/>
+          </a:ln>
+        </p:spPr>
+        <p:style>
+          <a:lnRef idx="1">
+            <a:schemeClr val="accent1"/>
+          </a:lnRef>
+          <a:fillRef idx="0">
+            <a:schemeClr val="accent1"/>
+          </a:fillRef>
+          <a:effectRef idx="0">
+            <a:schemeClr val="accent1"/>
+          </a:effectRef>
+          <a:fontRef idx="minor">
+            <a:schemeClr val="tx1"/>
+          </a:fontRef>
+        </p:style>
+      </p:cxnSp>
+      <p:cxnSp>
+        <p:nvCxnSpPr>
+          <p:cNvPr id="279" name="Connecteur droit avec flèche 278">
+            <a:extLst>
+              <a:ext uri="{FF2B5EF4-FFF2-40B4-BE49-F238E27FC236}">
+                <a16:creationId xmlns:a16="http://schemas.microsoft.com/office/drawing/2014/main" id="{07027E4A-A6DF-4651-B31B-0348AFB091F4}"/>
+              </a:ext>
+            </a:extLst>
+          </p:cNvPr>
+          <p:cNvCxnSpPr>
+            <a:cxnSpLocks/>
+            <a:stCxn id="174" idx="1"/>
+            <a:endCxn id="232" idx="3"/>
+          </p:cNvCxnSpPr>
+          <p:nvPr/>
+        </p:nvCxnSpPr>
+        <p:spPr>
+          <a:xfrm flipH="1" flipV="1">
+            <a:off x="8872926" y="2406243"/>
+            <a:ext cx="967291" cy="780508"/>
+          </a:xfrm>
+          <a:prstGeom prst="straightConnector1">
+            <a:avLst/>
+          </a:prstGeom>
+          <a:ln>
+            <a:headEnd type="triangle"/>
+            <a:tailEnd type="triangle"/>
+          </a:ln>
+        </p:spPr>
+        <p:style>
+          <a:lnRef idx="1">
+            <a:schemeClr val="accent1"/>
+          </a:lnRef>
+          <a:fillRef idx="0">
+            <a:schemeClr val="accent1"/>
+          </a:fillRef>
+          <a:effectRef idx="0">
+            <a:schemeClr val="accent1"/>
+          </a:effectRef>
+          <a:fontRef idx="minor">
+            <a:schemeClr val="tx1"/>
+          </a:fontRef>
+        </p:style>
+      </p:cxnSp>
+      <p:cxnSp>
+        <p:nvCxnSpPr>
+          <p:cNvPr id="282" name="Connecteur droit avec flèche 281">
+            <a:extLst>
+              <a:ext uri="{FF2B5EF4-FFF2-40B4-BE49-F238E27FC236}">
+                <a16:creationId xmlns:a16="http://schemas.microsoft.com/office/drawing/2014/main" id="{DEBB1C9C-3D9E-4EA6-B05E-B1C92B9B837D}"/>
+              </a:ext>
+            </a:extLst>
+          </p:cNvPr>
+          <p:cNvCxnSpPr>
+            <a:cxnSpLocks/>
+            <a:stCxn id="174" idx="0"/>
+            <a:endCxn id="230" idx="3"/>
+          </p:cNvCxnSpPr>
+          <p:nvPr/>
+        </p:nvCxnSpPr>
+        <p:spPr>
+          <a:xfrm flipH="1" flipV="1">
+            <a:off x="8834087" y="1359742"/>
+            <a:ext cx="1583170" cy="1720329"/>
+          </a:xfrm>
+          <a:prstGeom prst="straightConnector1">
+            <a:avLst/>
+          </a:prstGeom>
+          <a:ln>
+            <a:headEnd type="triangle"/>
+            <a:tailEnd type="triangle"/>
+          </a:ln>
+        </p:spPr>
+        <p:style>
+          <a:lnRef idx="1">
+            <a:schemeClr val="accent1"/>
+          </a:lnRef>
+          <a:fillRef idx="0">
+            <a:schemeClr val="accent1"/>
+          </a:fillRef>
+          <a:effectRef idx="0">
+            <a:schemeClr val="accent1"/>
+          </a:effectRef>
+          <a:fontRef idx="minor">
+            <a:schemeClr val="tx1"/>
+          </a:fontRef>
+        </p:style>
+      </p:cxnSp>
+      <p:cxnSp>
+        <p:nvCxnSpPr>
+          <p:cNvPr id="285" name="Connecteur droit avec flèche 284">
+            <a:extLst>
+              <a:ext uri="{FF2B5EF4-FFF2-40B4-BE49-F238E27FC236}">
+                <a16:creationId xmlns:a16="http://schemas.microsoft.com/office/drawing/2014/main" id="{197E7B99-DEFD-4536-9E2C-99DC5AF8F6E0}"/>
+              </a:ext>
+            </a:extLst>
+          </p:cNvPr>
+          <p:cNvCxnSpPr>
+            <a:cxnSpLocks/>
+            <a:stCxn id="174" idx="4"/>
+          </p:cNvCxnSpPr>
+          <p:nvPr/>
+        </p:nvCxnSpPr>
+        <p:spPr>
+          <a:xfrm flipH="1">
+            <a:off x="5403341" y="3808531"/>
+            <a:ext cx="5013916" cy="2121927"/>
+          </a:xfrm>
+          <a:prstGeom prst="straightConnector1">
+            <a:avLst/>
+          </a:prstGeom>
+          <a:ln>
+            <a:headEnd type="triangle"/>
+            <a:tailEnd type="triangle"/>
+          </a:ln>
+        </p:spPr>
+        <p:style>
+          <a:lnRef idx="1">
+            <a:schemeClr val="accent1"/>
+          </a:lnRef>
+          <a:fillRef idx="0">
+            <a:schemeClr val="accent1"/>
+          </a:fillRef>
+          <a:effectRef idx="0">
+            <a:schemeClr val="accent1"/>
+          </a:effectRef>
+          <a:fontRef idx="minor">
+            <a:schemeClr val="tx1"/>
+          </a:fontRef>
+        </p:style>
+      </p:cxnSp>
+    </p:spTree>
+    <p:extLst>
+      <p:ext uri="{BB962C8B-B14F-4D97-AF65-F5344CB8AC3E}">
+        <p14:creationId xmlns:p14="http://schemas.microsoft.com/office/powerpoint/2010/main" val="4242378882"/>
+      </p:ext>
+    </p:extLst>
+  </p:cSld>
+  <p:clrMapOvr>
+    <a:masterClrMapping/>
+  </p:clrMapOvr>
+</p:sld>
+</file>
+
+<file path=ppt/slides/slide4.xml><?xml version="1.0" encoding="utf-8"?>
+<p:sld xmlns:a="http://schemas.openxmlformats.org/drawingml/2006/main" xmlns:r="http://schemas.openxmlformats.org/officeDocument/2006/relationships" xmlns:p="http://schemas.openxmlformats.org/presentationml/2006/main">
+  <p:cSld>
+    <p:spTree>
+      <p:nvGrpSpPr>
+        <p:cNvPr id="1" name=""/>
+        <p:cNvGrpSpPr/>
+        <p:nvPr/>
+      </p:nvGrpSpPr>
+      <p:grpSpPr>
+        <a:xfrm>
+          <a:off x="0" y="0"/>
+          <a:ext cx="0" cy="0"/>
+          <a:chOff x="0" y="0"/>
+          <a:chExt cx="0" cy="0"/>
+        </a:xfrm>
+      </p:grpSpPr>
+      <p:sp>
+        <p:nvSpPr>
+          <p:cNvPr id="5" name="ZoneTexte 4">
+            <a:extLst>
+              <a:ext uri="{FF2B5EF4-FFF2-40B4-BE49-F238E27FC236}">
+                <a16:creationId xmlns:a16="http://schemas.microsoft.com/office/drawing/2014/main" id="{25D0CFDD-F8D9-4498-A666-F31BA473AEDD}"/>
+              </a:ext>
+            </a:extLst>
+          </p:cNvPr>
+          <p:cNvSpPr txBox="1"/>
+          <p:nvPr/>
+        </p:nvSpPr>
+        <p:spPr>
+          <a:xfrm>
+            <a:off x="3048000" y="3244334"/>
+            <a:ext cx="6096000" cy="369332"/>
+          </a:xfrm>
+          <a:prstGeom prst="rect">
+            <a:avLst/>
+          </a:prstGeom>
+          <a:noFill/>
+        </p:spPr>
+        <p:txBody>
+          <a:bodyPr wrap="square">
+            <a:spAutoFit/>
+          </a:bodyPr>
+          <a:lstStyle/>
+          <a:p>
+            <a:r>
+              <a:rPr lang="en-GB" dirty="0"/>
+              <a:t>10.  Connection Termination</a:t>
+            </a:r>
+          </a:p>
+        </p:txBody>
+      </p:sp>
+    </p:spTree>
+    <p:extLst>
+      <p:ext uri="{BB962C8B-B14F-4D97-AF65-F5344CB8AC3E}">
+        <p14:creationId xmlns:p14="http://schemas.microsoft.com/office/powerpoint/2010/main" val="3973114266"/>
       </p:ext>
     </p:extLst>
   </p:cSld>
@@ -5598,4 +8702,299 @@
     </a:ext>
   </a:extLst>
 </a:theme>
+</file>
+
+<file path=ppt/theme/theme2.xml><?xml version="1.0" encoding="utf-8"?>
+<a:theme xmlns:a="http://schemas.openxmlformats.org/drawingml/2006/main" name="Thème Office">
+  <a:themeElements>
+    <a:clrScheme name="Office">
+      <a:dk1>
+        <a:sysClr val="windowText" lastClr="000000"/>
+      </a:dk1>
+      <a:lt1>
+        <a:sysClr val="window" lastClr="FFFFFF"/>
+      </a:lt1>
+      <a:dk2>
+        <a:srgbClr val="44546A"/>
+      </a:dk2>
+      <a:lt2>
+        <a:srgbClr val="E7E6E6"/>
+      </a:lt2>
+      <a:accent1>
+        <a:srgbClr val="4472C4"/>
+      </a:accent1>
+      <a:accent2>
+        <a:srgbClr val="ED7D31"/>
+      </a:accent2>
+      <a:accent3>
+        <a:srgbClr val="A5A5A5"/>
+      </a:accent3>
+      <a:accent4>
+        <a:srgbClr val="FFC000"/>
+      </a:accent4>
+      <a:accent5>
+        <a:srgbClr val="5B9BD5"/>
+      </a:accent5>
+      <a:accent6>
+        <a:srgbClr val="70AD47"/>
+      </a:accent6>
+      <a:hlink>
+        <a:srgbClr val="0563C1"/>
+      </a:hlink>
+      <a:folHlink>
+        <a:srgbClr val="954F72"/>
+      </a:folHlink>
+    </a:clrScheme>
+    <a:fontScheme name="Office">
+      <a:majorFont>
+        <a:latin typeface="Calibri Light" panose="020F0302020204030204"/>
+        <a:ea typeface=""/>
+        <a:cs typeface=""/>
+        <a:font script="Jpan" typeface="游ゴシック Light"/>
+        <a:font script="Hang" typeface="맑은 고딕"/>
+        <a:font script="Hans" typeface="等线 Light"/>
+        <a:font script="Hant" typeface="新細明體"/>
+        <a:font script="Arab" typeface="Times New Roman"/>
+        <a:font script="Hebr" typeface="Times New Roman"/>
+        <a:font script="Thai" typeface="Angsana New"/>
+        <a:font script="Ethi" typeface="Nyala"/>
+        <a:font script="Beng" typeface="Vrinda"/>
+        <a:font script="Gujr" typeface="Shruti"/>
+        <a:font script="Khmr" typeface="MoolBoran"/>
+        <a:font script="Knda" typeface="Tunga"/>
+        <a:font script="Guru" typeface="Raavi"/>
+        <a:font script="Cans" typeface="Euphemia"/>
+        <a:font script="Cher" typeface="Plantagenet Cherokee"/>
+        <a:font script="Yiii" typeface="Microsoft Yi Baiti"/>
+        <a:font script="Tibt" typeface="Microsoft Himalaya"/>
+        <a:font script="Thaa" typeface="MV Boli"/>
+        <a:font script="Deva" typeface="Mangal"/>
+        <a:font script="Telu" typeface="Gautami"/>
+        <a:font script="Taml" typeface="Latha"/>
+        <a:font script="Syrc" typeface="Estrangelo Edessa"/>
+        <a:font script="Orya" typeface="Kalinga"/>
+        <a:font script="Mlym" typeface="Kartika"/>
+        <a:font script="Laoo" typeface="DokChampa"/>
+        <a:font script="Sinh" typeface="Iskoola Pota"/>
+        <a:font script="Mong" typeface="Mongolian Baiti"/>
+        <a:font script="Viet" typeface="Times New Roman"/>
+        <a:font script="Uigh" typeface="Microsoft Uighur"/>
+        <a:font script="Geor" typeface="Sylfaen"/>
+        <a:font script="Armn" typeface="Arial"/>
+        <a:font script="Bugi" typeface="Leelawadee UI"/>
+        <a:font script="Bopo" typeface="Microsoft JhengHei"/>
+        <a:font script="Java" typeface="Javanese Text"/>
+        <a:font script="Lisu" typeface="Segoe UI"/>
+        <a:font script="Mymr" typeface="Myanmar Text"/>
+        <a:font script="Nkoo" typeface="Ebrima"/>
+        <a:font script="Olck" typeface="Nirmala UI"/>
+        <a:font script="Osma" typeface="Ebrima"/>
+        <a:font script="Phag" typeface="Phagspa"/>
+        <a:font script="Syrn" typeface="Estrangelo Edessa"/>
+        <a:font script="Syrj" typeface="Estrangelo Edessa"/>
+        <a:font script="Syre" typeface="Estrangelo Edessa"/>
+        <a:font script="Sora" typeface="Nirmala UI"/>
+        <a:font script="Tale" typeface="Microsoft Tai Le"/>
+        <a:font script="Talu" typeface="Microsoft New Tai Lue"/>
+        <a:font script="Tfng" typeface="Ebrima"/>
+      </a:majorFont>
+      <a:minorFont>
+        <a:latin typeface="Calibri" panose="020F0502020204030204"/>
+        <a:ea typeface=""/>
+        <a:cs typeface=""/>
+        <a:font script="Jpan" typeface="游ゴシック"/>
+        <a:font script="Hang" typeface="맑은 고딕"/>
+        <a:font script="Hans" typeface="等线"/>
+        <a:font script="Hant" typeface="新細明體"/>
+        <a:font script="Arab" typeface="Arial"/>
+        <a:font script="Hebr" typeface="Arial"/>
+        <a:font script="Thai" typeface="Cordia New"/>
+        <a:font script="Ethi" typeface="Nyala"/>
+        <a:font script="Beng" typeface="Vrinda"/>
+        <a:font script="Gujr" typeface="Shruti"/>
+        <a:font script="Khmr" typeface="DaunPenh"/>
+        <a:font script="Knda" typeface="Tunga"/>
+        <a:font script="Guru" typeface="Raavi"/>
+        <a:font script="Cans" typeface="Euphemia"/>
+        <a:font script="Cher" typeface="Plantagenet Cherokee"/>
+        <a:font script="Yiii" typeface="Microsoft Yi Baiti"/>
+        <a:font script="Tibt" typeface="Microsoft Himalaya"/>
+        <a:font script="Thaa" typeface="MV Boli"/>
+        <a:font script="Deva" typeface="Mangal"/>
+        <a:font script="Telu" typeface="Gautami"/>
+        <a:font script="Taml" typeface="Latha"/>
+        <a:font script="Syrc" typeface="Estrangelo Edessa"/>
+        <a:font script="Orya" typeface="Kalinga"/>
+        <a:font script="Mlym" typeface="Kartika"/>
+        <a:font script="Laoo" typeface="DokChampa"/>
+        <a:font script="Sinh" typeface="Iskoola Pota"/>
+        <a:font script="Mong" typeface="Mongolian Baiti"/>
+        <a:font script="Viet" typeface="Arial"/>
+        <a:font script="Uigh" typeface="Microsoft Uighur"/>
+        <a:font script="Geor" typeface="Sylfaen"/>
+        <a:font script="Armn" typeface="Arial"/>
+        <a:font script="Bugi" typeface="Leelawadee UI"/>
+        <a:font script="Bopo" typeface="Microsoft JhengHei"/>
+        <a:font script="Java" typeface="Javanese Text"/>
+        <a:font script="Lisu" typeface="Segoe UI"/>
+        <a:font script="Mymr" typeface="Myanmar Text"/>
+        <a:font script="Nkoo" typeface="Ebrima"/>
+        <a:font script="Olck" typeface="Nirmala UI"/>
+        <a:font script="Osma" typeface="Ebrima"/>
+        <a:font script="Phag" typeface="Phagspa"/>
+        <a:font script="Syrn" typeface="Estrangelo Edessa"/>
+        <a:font script="Syrj" typeface="Estrangelo Edessa"/>
+        <a:font script="Syre" typeface="Estrangelo Edessa"/>
+        <a:font script="Sora" typeface="Nirmala UI"/>
+        <a:font script="Tale" typeface="Microsoft Tai Le"/>
+        <a:font script="Talu" typeface="Microsoft New Tai Lue"/>
+        <a:font script="Tfng" typeface="Ebrima"/>
+      </a:minorFont>
+    </a:fontScheme>
+    <a:fmtScheme name="Office">
+      <a:fillStyleLst>
+        <a:solidFill>
+          <a:schemeClr val="phClr"/>
+        </a:solidFill>
+        <a:gradFill rotWithShape="1">
+          <a:gsLst>
+            <a:gs pos="0">
+              <a:schemeClr val="phClr">
+                <a:lumMod val="110000"/>
+                <a:satMod val="105000"/>
+                <a:tint val="67000"/>
+              </a:schemeClr>
+            </a:gs>
+            <a:gs pos="50000">
+              <a:schemeClr val="phClr">
+                <a:lumMod val="105000"/>
+                <a:satMod val="103000"/>
+                <a:tint val="73000"/>
+              </a:schemeClr>
+            </a:gs>
+            <a:gs pos="100000">
+              <a:schemeClr val="phClr">
+                <a:lumMod val="105000"/>
+                <a:satMod val="109000"/>
+                <a:tint val="81000"/>
+              </a:schemeClr>
+            </a:gs>
+          </a:gsLst>
+          <a:lin ang="5400000" scaled="0"/>
+        </a:gradFill>
+        <a:gradFill rotWithShape="1">
+          <a:gsLst>
+            <a:gs pos="0">
+              <a:schemeClr val="phClr">
+                <a:satMod val="103000"/>
+                <a:lumMod val="102000"/>
+                <a:tint val="94000"/>
+              </a:schemeClr>
+            </a:gs>
+            <a:gs pos="50000">
+              <a:schemeClr val="phClr">
+                <a:satMod val="110000"/>
+                <a:lumMod val="100000"/>
+                <a:shade val="100000"/>
+              </a:schemeClr>
+            </a:gs>
+            <a:gs pos="100000">
+              <a:schemeClr val="phClr">
+                <a:lumMod val="99000"/>
+                <a:satMod val="120000"/>
+                <a:shade val="78000"/>
+              </a:schemeClr>
+            </a:gs>
+          </a:gsLst>
+          <a:lin ang="5400000" scaled="0"/>
+        </a:gradFill>
+      </a:fillStyleLst>
+      <a:lnStyleLst>
+        <a:ln w="6350" cap="flat" cmpd="sng" algn="ctr">
+          <a:solidFill>
+            <a:schemeClr val="phClr"/>
+          </a:solidFill>
+          <a:prstDash val="solid"/>
+          <a:miter lim="800000"/>
+        </a:ln>
+        <a:ln w="12700" cap="flat" cmpd="sng" algn="ctr">
+          <a:solidFill>
+            <a:schemeClr val="phClr"/>
+          </a:solidFill>
+          <a:prstDash val="solid"/>
+          <a:miter lim="800000"/>
+        </a:ln>
+        <a:ln w="19050" cap="flat" cmpd="sng" algn="ctr">
+          <a:solidFill>
+            <a:schemeClr val="phClr"/>
+          </a:solidFill>
+          <a:prstDash val="solid"/>
+          <a:miter lim="800000"/>
+        </a:ln>
+      </a:lnStyleLst>
+      <a:effectStyleLst>
+        <a:effectStyle>
+          <a:effectLst/>
+        </a:effectStyle>
+        <a:effectStyle>
+          <a:effectLst/>
+        </a:effectStyle>
+        <a:effectStyle>
+          <a:effectLst>
+            <a:outerShdw blurRad="57150" dist="19050" dir="5400000" algn="ctr" rotWithShape="0">
+              <a:srgbClr val="000000">
+                <a:alpha val="63000"/>
+              </a:srgbClr>
+            </a:outerShdw>
+          </a:effectLst>
+        </a:effectStyle>
+      </a:effectStyleLst>
+      <a:bgFillStyleLst>
+        <a:solidFill>
+          <a:schemeClr val="phClr"/>
+        </a:solidFill>
+        <a:solidFill>
+          <a:schemeClr val="phClr">
+            <a:tint val="95000"/>
+            <a:satMod val="170000"/>
+          </a:schemeClr>
+        </a:solidFill>
+        <a:gradFill rotWithShape="1">
+          <a:gsLst>
+            <a:gs pos="0">
+              <a:schemeClr val="phClr">
+                <a:tint val="93000"/>
+                <a:satMod val="150000"/>
+                <a:shade val="98000"/>
+                <a:lumMod val="102000"/>
+              </a:schemeClr>
+            </a:gs>
+            <a:gs pos="50000">
+              <a:schemeClr val="phClr">
+                <a:tint val="98000"/>
+                <a:satMod val="130000"/>
+                <a:shade val="90000"/>
+                <a:lumMod val="103000"/>
+              </a:schemeClr>
+            </a:gs>
+            <a:gs pos="100000">
+              <a:schemeClr val="phClr">
+                <a:shade val="63000"/>
+                <a:satMod val="120000"/>
+              </a:schemeClr>
+            </a:gs>
+          </a:gsLst>
+          <a:lin ang="5400000" scaled="0"/>
+        </a:gradFill>
+      </a:bgFillStyleLst>
+    </a:fmtScheme>
+  </a:themeElements>
+  <a:objectDefaults/>
+  <a:extraClrSchemeLst/>
+  <a:extLst>
+    <a:ext uri="{05A4C25C-085E-4340-85A3-A5531E510DB2}">
+      <thm15:themeFamily xmlns:thm15="http://schemas.microsoft.com/office/thememl/2012/main" name="Office Theme" id="{62F939B6-93AF-4DB8-9C6B-D6C7DFDC589F}" vid="{4A3C46E8-61CC-4603-A589-7422A47A8E4A}"/>
+    </a:ext>
+  </a:extLst>
+</a:theme>
 </file>
</xml_diff>